<commit_message>
docs(week6): complete demo flow and tool coverage
</commit_message>
<xml_diff>
--- a/docs/demo-slides.pptx
+++ b/docs/demo-slides.pptx
@@ -5,12 +5,14 @@
     <p:sldMasterId id="2147483648" r:id="rId1"/>
   </p:sldMasterIdLst>
   <p:notesMasterIdLst>
-    <p:notesMasterId r:id="rId5"/>
+    <p:notesMasterId r:id="rId7"/>
   </p:notesMasterIdLst>
   <p:sldIdLst>
     <p:sldId id="256" r:id="rId2"/>
     <p:sldId id="257" r:id="rId3"/>
     <p:sldId id="258" r:id="rId4"/>
+    <p:sldId id="259" r:id="rId5"/>
+    <p:sldId id="260" r:id="rId6"/>
   </p:sldIdLst>
   <p:sldSz cx="12192000" cy="6858000"/>
   <p:notesSz cx="6858000" cy="12192000"/>
@@ -106,6 +108,11 @@
       </a:defRPr>
     </a:lvl9pPr>
   </p:defaultTextStyle>
+  <p:extLst>
+    <p:ext uri="{EFAFB233-063F-42B5-8137-9DF3F51BA10A}">
+      <p15:sldGuideLst xmlns:p15="http://schemas.microsoft.com/office/powerpoint/2012/main"/>
+    </p:ext>
+  </p:extLst>
 </p:presentation>
 </file>
 
@@ -131,241 +138,16 @@
           <a:chExt cx="0" cy="0"/>
         </a:xfrm>
       </p:grpSpPr>
-      <p:sp>
-        <p:nvSpPr>
-          <p:cNvPr id="2" name="Header Placeholder 1"/>
-          <p:cNvSpPr>
-            <a:spLocks noGrp="1"/>
-          </p:cNvSpPr>
-          <p:nvPr>
-            <p:ph type="hdr" sz="quarter"/>
-          </p:nvPr>
-        </p:nvSpPr>
-        <p:spPr>
-          <a:xfrm>
-            <a:off x="3886200" y="0"/>
-            <a:ext cx="2971800" cy="609600"/>
-          </a:xfrm>
-          <a:prstGeom prst="rect">
-            <a:avLst/>
-          </a:prstGeom>
-        </p:spPr>
-        <p:txBody>
-          <a:bodyPr vert="horz" lIns="91440" tIns="45720" rIns="91440" bIns="45720" rtlCol="1"/>
-          <a:lstStyle>
-            <a:lvl1pPr algn="r">
-              <a:defRPr sz="1200"/>
-            </a:lvl1pPr>
-          </a:lstStyle>
-          <a:p>
-            <a:endParaRPr lang="ar-SA"/>
-          </a:p>
-        </p:txBody>
-      </p:sp>
-      <p:sp>
-        <p:nvSpPr>
-          <p:cNvPr id="3" name="Date Placeholder 2"/>
-          <p:cNvSpPr>
-            <a:spLocks noGrp="1"/>
-          </p:cNvSpPr>
-          <p:nvPr>
-            <p:ph type="dt" idx="1"/>
-          </p:nvPr>
-        </p:nvSpPr>
-        <p:spPr>
-          <a:xfrm>
-            <a:off x="1588" y="0"/>
-            <a:ext cx="2971800" cy="609600"/>
-          </a:xfrm>
-          <a:prstGeom prst="rect">
-            <a:avLst/>
-          </a:prstGeom>
-        </p:spPr>
-        <p:txBody>
-          <a:bodyPr vert="horz" lIns="91440" tIns="45720" rIns="91440" bIns="45720" rtlCol="1"/>
-          <a:lstStyle>
-            <a:lvl1pPr algn="l">
-              <a:defRPr sz="1200"/>
-            </a:lvl1pPr>
-          </a:lstStyle>
-          <a:p>
-            <a:fld id="{348DEE78-52B5-4ED4-9C40-D54C7EC1C00B}" type="datetimeFigureOut">
-              <a:rPr lang="ar-SA" smtClean="0"/>
-              <a:t>10/03/1448</a:t>
-            </a:fld>
-            <a:endParaRPr lang="ar-SA"/>
-          </a:p>
-        </p:txBody>
-      </p:sp>
-      <p:sp>
-        <p:nvSpPr>
-          <p:cNvPr id="4" name="Slide Image Placeholder 3"/>
-          <p:cNvSpPr>
-            <a:spLocks noGrp="1" noRot="1" noChangeAspect="1"/>
-          </p:cNvSpPr>
-          <p:nvPr>
-            <p:ph type="sldImg" idx="2"/>
-          </p:nvPr>
-        </p:nvSpPr>
-        <p:spPr>
-          <a:xfrm>
-            <a:off x="-635000" y="914400"/>
-            <a:ext cx="8128000" cy="4572000"/>
-          </a:xfrm>
-          <a:prstGeom prst="rect">
-            <a:avLst/>
-          </a:prstGeom>
-          <a:noFill/>
-          <a:ln w="12700">
-            <a:solidFill>
-              <a:prstClr val="black"/>
-            </a:solidFill>
-          </a:ln>
-        </p:spPr>
-        <p:txBody>
-          <a:bodyPr vert="horz" lIns="91440" tIns="45720" rIns="91440" bIns="45720" rtlCol="1" anchor="ctr"/>
-          <a:lstStyle/>
-          <a:p>
-            <a:endParaRPr lang="ar-SA"/>
-          </a:p>
-        </p:txBody>
-      </p:sp>
-      <p:sp>
-        <p:nvSpPr>
-          <p:cNvPr id="5" name="Notes Placeholder 4"/>
-          <p:cNvSpPr>
-            <a:spLocks noGrp="1"/>
-          </p:cNvSpPr>
-          <p:nvPr>
-            <p:ph type="body" sz="quarter" idx="3"/>
-          </p:nvPr>
-        </p:nvSpPr>
-        <p:spPr>
-          <a:xfrm>
-            <a:off x="685800" y="5791200"/>
-            <a:ext cx="5486400" cy="5486400"/>
-          </a:xfrm>
-          <a:prstGeom prst="rect">
-            <a:avLst/>
-          </a:prstGeom>
-        </p:spPr>
-        <p:txBody>
-          <a:bodyPr vert="horz" lIns="91440" tIns="45720" rIns="91440" bIns="45720" rtlCol="1"/>
-          <a:lstStyle/>
-          <a:p>
-            <a:pPr lvl="0"/>
-            <a:r>
-              <a:rPr lang="en-US" smtClean="0"/>
-              <a:t>Click to edit Master text styles</a:t>
-            </a:r>
-          </a:p>
-          <a:p>
-            <a:pPr lvl="1"/>
-            <a:r>
-              <a:rPr lang="en-US" smtClean="0"/>
-              <a:t>Second level</a:t>
-            </a:r>
-          </a:p>
-          <a:p>
-            <a:pPr lvl="2"/>
-            <a:r>
-              <a:rPr lang="en-US" smtClean="0"/>
-              <a:t>Third level</a:t>
-            </a:r>
-          </a:p>
-          <a:p>
-            <a:pPr lvl="3"/>
-            <a:r>
-              <a:rPr lang="en-US" smtClean="0"/>
-              <a:t>Fourth level</a:t>
-            </a:r>
-          </a:p>
-          <a:p>
-            <a:pPr lvl="4"/>
-            <a:r>
-              <a:rPr lang="en-US" smtClean="0"/>
-              <a:t>Fifth level</a:t>
-            </a:r>
-            <a:endParaRPr lang="ar-SA"/>
-          </a:p>
-        </p:txBody>
-      </p:sp>
-      <p:sp>
-        <p:nvSpPr>
-          <p:cNvPr id="6" name="Footer Placeholder 5"/>
-          <p:cNvSpPr>
-            <a:spLocks noGrp="1"/>
-          </p:cNvSpPr>
-          <p:nvPr>
-            <p:ph type="ftr" sz="quarter" idx="4"/>
-          </p:nvPr>
-        </p:nvSpPr>
-        <p:spPr>
-          <a:xfrm>
-            <a:off x="3886200" y="11580813"/>
-            <a:ext cx="2971800" cy="609600"/>
-          </a:xfrm>
-          <a:prstGeom prst="rect">
-            <a:avLst/>
-          </a:prstGeom>
-        </p:spPr>
-        <p:txBody>
-          <a:bodyPr vert="horz" lIns="91440" tIns="45720" rIns="91440" bIns="45720" rtlCol="1" anchor="b"/>
-          <a:lstStyle>
-            <a:lvl1pPr algn="r">
-              <a:defRPr sz="1200"/>
-            </a:lvl1pPr>
-          </a:lstStyle>
-          <a:p>
-            <a:endParaRPr lang="ar-SA"/>
-          </a:p>
-        </p:txBody>
-      </p:sp>
-      <p:sp>
-        <p:nvSpPr>
-          <p:cNvPr id="7" name="Slide Number Placeholder 6"/>
-          <p:cNvSpPr>
-            <a:spLocks noGrp="1"/>
-          </p:cNvSpPr>
-          <p:nvPr>
-            <p:ph type="sldNum" sz="quarter" idx="5"/>
-          </p:nvPr>
-        </p:nvSpPr>
-        <p:spPr>
-          <a:xfrm>
-            <a:off x="1588" y="11580813"/>
-            <a:ext cx="2971800" cy="609600"/>
-          </a:xfrm>
-          <a:prstGeom prst="rect">
-            <a:avLst/>
-          </a:prstGeom>
-        </p:spPr>
-        <p:txBody>
-          <a:bodyPr vert="horz" lIns="91440" tIns="45720" rIns="91440" bIns="45720" rtlCol="1" anchor="b"/>
-          <a:lstStyle>
-            <a:lvl1pPr algn="l">
-              <a:defRPr sz="1200"/>
-            </a:lvl1pPr>
-          </a:lstStyle>
-          <a:p>
-            <a:fld id="{00EEEE06-C8FB-487A-B8B6-8B759C4104CF}" type="slidenum">
-              <a:rPr lang="ar-SA" smtClean="0"/>
-              <a:t>‹#›</a:t>
-            </a:fld>
-            <a:endParaRPr lang="ar-SA"/>
-          </a:p>
-        </p:txBody>
-      </p:sp>
     </p:spTree>
     <p:extLst>
       <p:ext uri="{BB962C8B-B14F-4D97-AF65-F5344CB8AC3E}">
-        <p14:creationId xmlns:p14="http://schemas.microsoft.com/office/powerpoint/2010/main" val="677259299"/>
+        <p14:creationId xmlns:p14="http://schemas.microsoft.com/office/powerpoint/2010/main" val="279848868"/>
       </p:ext>
     </p:extLst>
   </p:cSld>
   <p:clrMap bg1="lt1" tx1="dk1" bg2="lt2" tx2="dk2" accent1="accent1" accent2="accent2" accent3="accent3" accent4="accent4" accent5="accent5" accent6="accent6" hlink="hlink" folHlink="folHlink"/>
   <p:notesStyle>
-    <a:lvl1pPr marL="0" algn="r" defTabSz="914400" rtl="1" eaLnBrk="1" latinLnBrk="0" hangingPunct="1">
+    <a:lvl1pPr marL="0" algn="l" defTabSz="914400" rtl="0" eaLnBrk="1" latinLnBrk="0" hangingPunct="1">
       <a:defRPr sz="1200" kern="1200">
         <a:solidFill>
           <a:schemeClr val="tx1"/>
@@ -375,7 +157,7 @@
         <a:cs typeface="+mn-cs"/>
       </a:defRPr>
     </a:lvl1pPr>
-    <a:lvl2pPr marL="457200" algn="r" defTabSz="914400" rtl="1" eaLnBrk="1" latinLnBrk="0" hangingPunct="1">
+    <a:lvl2pPr marL="457200" algn="l" defTabSz="914400" rtl="0" eaLnBrk="1" latinLnBrk="0" hangingPunct="1">
       <a:defRPr sz="1200" kern="1200">
         <a:solidFill>
           <a:schemeClr val="tx1"/>
@@ -385,7 +167,7 @@
         <a:cs typeface="+mn-cs"/>
       </a:defRPr>
     </a:lvl2pPr>
-    <a:lvl3pPr marL="914400" algn="r" defTabSz="914400" rtl="1" eaLnBrk="1" latinLnBrk="0" hangingPunct="1">
+    <a:lvl3pPr marL="914400" algn="l" defTabSz="914400" rtl="0" eaLnBrk="1" latinLnBrk="0" hangingPunct="1">
       <a:defRPr sz="1200" kern="1200">
         <a:solidFill>
           <a:schemeClr val="tx1"/>
@@ -395,7 +177,7 @@
         <a:cs typeface="+mn-cs"/>
       </a:defRPr>
     </a:lvl3pPr>
-    <a:lvl4pPr marL="1371600" algn="r" defTabSz="914400" rtl="1" eaLnBrk="1" latinLnBrk="0" hangingPunct="1">
+    <a:lvl4pPr marL="1371600" algn="l" defTabSz="914400" rtl="0" eaLnBrk="1" latinLnBrk="0" hangingPunct="1">
       <a:defRPr sz="1200" kern="1200">
         <a:solidFill>
           <a:schemeClr val="tx1"/>
@@ -405,7 +187,7 @@
         <a:cs typeface="+mn-cs"/>
       </a:defRPr>
     </a:lvl4pPr>
-    <a:lvl5pPr marL="1828800" algn="r" defTabSz="914400" rtl="1" eaLnBrk="1" latinLnBrk="0" hangingPunct="1">
+    <a:lvl5pPr marL="1828800" algn="l" defTabSz="914400" rtl="0" eaLnBrk="1" latinLnBrk="0" hangingPunct="1">
       <a:defRPr sz="1200" kern="1200">
         <a:solidFill>
           <a:schemeClr val="tx1"/>
@@ -415,7 +197,7 @@
         <a:cs typeface="+mn-cs"/>
       </a:defRPr>
     </a:lvl5pPr>
-    <a:lvl6pPr marL="2286000" algn="r" defTabSz="914400" rtl="1" eaLnBrk="1" latinLnBrk="0" hangingPunct="1">
+    <a:lvl6pPr marL="2286000" algn="l" defTabSz="914400" rtl="0" eaLnBrk="1" latinLnBrk="0" hangingPunct="1">
       <a:defRPr sz="1200" kern="1200">
         <a:solidFill>
           <a:schemeClr val="tx1"/>
@@ -425,7 +207,7 @@
         <a:cs typeface="+mn-cs"/>
       </a:defRPr>
     </a:lvl6pPr>
-    <a:lvl7pPr marL="2743200" algn="r" defTabSz="914400" rtl="1" eaLnBrk="1" latinLnBrk="0" hangingPunct="1">
+    <a:lvl7pPr marL="2743200" algn="l" defTabSz="914400" rtl="0" eaLnBrk="1" latinLnBrk="0" hangingPunct="1">
       <a:defRPr sz="1200" kern="1200">
         <a:solidFill>
           <a:schemeClr val="tx1"/>
@@ -435,7 +217,7 @@
         <a:cs typeface="+mn-cs"/>
       </a:defRPr>
     </a:lvl7pPr>
-    <a:lvl8pPr marL="3200400" algn="r" defTabSz="914400" rtl="1" eaLnBrk="1" latinLnBrk="0" hangingPunct="1">
+    <a:lvl8pPr marL="3200400" algn="l" defTabSz="914400" rtl="0" eaLnBrk="1" latinLnBrk="0" hangingPunct="1">
       <a:defRPr sz="1200" kern="1200">
         <a:solidFill>
           <a:schemeClr val="tx1"/>
@@ -445,7 +227,7 @@
         <a:cs typeface="+mn-cs"/>
       </a:defRPr>
     </a:lvl8pPr>
-    <a:lvl9pPr marL="3657600" algn="r" defTabSz="914400" rtl="1" eaLnBrk="1" latinLnBrk="0" hangingPunct="1">
+    <a:lvl9pPr marL="3657600" algn="l" defTabSz="914400" rtl="0" eaLnBrk="1" latinLnBrk="0" hangingPunct="1">
       <a:defRPr sz="1200" kern="1200">
         <a:solidFill>
           <a:schemeClr val="tx1"/>
@@ -693,6 +475,174 @@
             <a:fld id="{F7021451-1387-4CA6-816F-3879F97B5CBC}" type="slidenum">
               <a:rPr lang="en-US"/>
               <a:t>3</a:t>
+            </a:fld>
+            <a:endParaRPr lang="en-US"/>
+          </a:p>
+        </p:txBody>
+      </p:sp>
+    </p:spTree>
+    <p:extLst>
+      <p:ext uri="{BB962C8B-B14F-4D97-AF65-F5344CB8AC3E}">
+        <p14:creationId xmlns:p14="http://schemas.microsoft.com/office/powerpoint/2010/main" val="1024086991"/>
+      </p:ext>
+    </p:extLst>
+  </p:cSld>
+  <p:clrMapOvr>
+    <a:masterClrMapping/>
+  </p:clrMapOvr>
+</p:notes>
+</file>
+
+<file path=ppt/notesSlides/notesSlide4.xml><?xml version="1.0" encoding="utf-8"?>
+<p:notes xmlns:a="http://schemas.openxmlformats.org/drawingml/2006/main" xmlns:r="http://schemas.openxmlformats.org/officeDocument/2006/relationships" xmlns:p="http://schemas.openxmlformats.org/presentationml/2006/main">
+  <p:cSld>
+    <p:spTree>
+      <p:nvGrpSpPr>
+        <p:cNvPr id="1" name=""/>
+        <p:cNvGrpSpPr/>
+        <p:nvPr/>
+      </p:nvGrpSpPr>
+      <p:grpSpPr>
+        <a:xfrm>
+          <a:off x="0" y="0"/>
+          <a:ext cx="0" cy="0"/>
+          <a:chOff x="0" y="0"/>
+          <a:chExt cx="0" cy="0"/>
+        </a:xfrm>
+      </p:grpSpPr>
+      <p:sp>
+        <p:nvSpPr>
+          <p:cNvPr id="2" name="Slide Image Placeholder 1"/>
+          <p:cNvSpPr>
+            <a:spLocks noGrp="1" noRot="1" noChangeAspect="1"/>
+          </p:cNvSpPr>
+          <p:nvPr>
+            <p:ph type="sldImg"/>
+          </p:nvPr>
+        </p:nvSpPr>
+        <p:spPr/>
+      </p:sp>
+      <p:sp>
+        <p:nvSpPr>
+          <p:cNvPr id="3" name="Notes Placeholder 2"/>
+          <p:cNvSpPr>
+            <a:spLocks noGrp="1"/>
+          </p:cNvSpPr>
+          <p:nvPr>
+            <p:ph type="body" idx="1"/>
+          </p:nvPr>
+        </p:nvSpPr>
+        <p:spPr/>
+        <p:txBody>
+          <a:bodyPr/>
+          <a:lstStyle/>
+          <a:p>
+            <a:endParaRPr lang="en-US" dirty="0"/>
+          </a:p>
+        </p:txBody>
+      </p:sp>
+      <p:sp>
+        <p:nvSpPr>
+          <p:cNvPr id="4" name="Slide Number Placeholder 3"/>
+          <p:cNvSpPr>
+            <a:spLocks noGrp="1"/>
+          </p:cNvSpPr>
+          <p:nvPr>
+            <p:ph type="sldNum" sz="quarter" idx="10"/>
+          </p:nvPr>
+        </p:nvSpPr>
+        <p:spPr/>
+        <p:txBody>
+          <a:bodyPr/>
+          <a:lstStyle/>
+          <a:p>
+            <a:fld id="{F7021451-1387-4CA6-816F-3879F97B5CBC}" type="slidenum">
+              <a:rPr lang="en-US"/>
+              <a:t>4</a:t>
+            </a:fld>
+            <a:endParaRPr lang="en-US"/>
+          </a:p>
+        </p:txBody>
+      </p:sp>
+    </p:spTree>
+    <p:extLst>
+      <p:ext uri="{BB962C8B-B14F-4D97-AF65-F5344CB8AC3E}">
+        <p14:creationId xmlns:p14="http://schemas.microsoft.com/office/powerpoint/2010/main" val="1024086991"/>
+      </p:ext>
+    </p:extLst>
+  </p:cSld>
+  <p:clrMapOvr>
+    <a:masterClrMapping/>
+  </p:clrMapOvr>
+</p:notes>
+</file>
+
+<file path=ppt/notesSlides/notesSlide5.xml><?xml version="1.0" encoding="utf-8"?>
+<p:notes xmlns:a="http://schemas.openxmlformats.org/drawingml/2006/main" xmlns:r="http://schemas.openxmlformats.org/officeDocument/2006/relationships" xmlns:p="http://schemas.openxmlformats.org/presentationml/2006/main">
+  <p:cSld>
+    <p:spTree>
+      <p:nvGrpSpPr>
+        <p:cNvPr id="1" name=""/>
+        <p:cNvGrpSpPr/>
+        <p:nvPr/>
+      </p:nvGrpSpPr>
+      <p:grpSpPr>
+        <a:xfrm>
+          <a:off x="0" y="0"/>
+          <a:ext cx="0" cy="0"/>
+          <a:chOff x="0" y="0"/>
+          <a:chExt cx="0" cy="0"/>
+        </a:xfrm>
+      </p:grpSpPr>
+      <p:sp>
+        <p:nvSpPr>
+          <p:cNvPr id="2" name="Slide Image Placeholder 1"/>
+          <p:cNvSpPr>
+            <a:spLocks noGrp="1" noRot="1" noChangeAspect="1"/>
+          </p:cNvSpPr>
+          <p:nvPr>
+            <p:ph type="sldImg"/>
+          </p:nvPr>
+        </p:nvSpPr>
+        <p:spPr/>
+      </p:sp>
+      <p:sp>
+        <p:nvSpPr>
+          <p:cNvPr id="3" name="Notes Placeholder 2"/>
+          <p:cNvSpPr>
+            <a:spLocks noGrp="1"/>
+          </p:cNvSpPr>
+          <p:nvPr>
+            <p:ph type="body" idx="1"/>
+          </p:nvPr>
+        </p:nvSpPr>
+        <p:spPr/>
+        <p:txBody>
+          <a:bodyPr/>
+          <a:lstStyle/>
+          <a:p>
+            <a:endParaRPr lang="en-US" dirty="0"/>
+          </a:p>
+        </p:txBody>
+      </p:sp>
+      <p:sp>
+        <p:nvSpPr>
+          <p:cNvPr id="4" name="Slide Number Placeholder 3"/>
+          <p:cNvSpPr>
+            <a:spLocks noGrp="1"/>
+          </p:cNvSpPr>
+          <p:nvPr>
+            <p:ph type="sldNum" sz="quarter" idx="10"/>
+          </p:nvPr>
+        </p:nvSpPr>
+        <p:spPr/>
+        <p:txBody>
+          <a:bodyPr/>
+          <a:lstStyle/>
+          <a:p>
+            <a:fld id="{F7021451-1387-4CA6-816F-3879F97B5CBC}" type="slidenum">
+              <a:rPr lang="en-US"/>
+              <a:t>5</a:t>
             </a:fld>
             <a:endParaRPr lang="en-US"/>
           </a:p>
@@ -1544,11 +1494,8 @@
           <a:bodyPr wrap="square" lIns="0" tIns="0" rIns="0" bIns="0" rtlCol="0" anchor="ctr"/>
           <a:lstStyle/>
           <a:p>
-            <a:pPr marL="0" indent="0">
-              <a:buNone/>
-            </a:pPr>
-            <a:r>
-              <a:rPr lang="en-US" sz="1100" dirty="0" err="1" smtClean="0">
+            <a:r>
+              <a:rPr lang="en-US" sz="1100" dirty="0" err="1">
                 <a:solidFill>
                   <a:srgbClr val="6B7280"/>
                 </a:solidFill>
@@ -1556,7 +1503,7 @@
               <a:t>Saja</a:t>
             </a:r>
             <a:r>
-              <a:rPr lang="en-US" sz="1100" dirty="0" smtClean="0">
+              <a:rPr lang="en-US" sz="1100" dirty="0">
                 <a:solidFill>
                   <a:srgbClr val="6B7280"/>
                 </a:solidFill>
@@ -1564,7 +1511,7 @@
               <a:t> </a:t>
             </a:r>
             <a:r>
-              <a:rPr lang="en-US" sz="1100" dirty="0" err="1" smtClean="0">
+              <a:rPr lang="en-US" sz="1100" dirty="0" err="1">
                 <a:solidFill>
                   <a:srgbClr val="6B7280"/>
                 </a:solidFill>
@@ -1572,69 +1519,51 @@
               <a:t>Asfour</a:t>
             </a:r>
             <a:r>
-              <a:rPr lang="en-US" sz="1100" dirty="0" smtClean="0">
+              <a:rPr lang="en-US" sz="1100" dirty="0">
                 <a:solidFill>
                   <a:srgbClr val="6B7280"/>
                 </a:solidFill>
               </a:rPr>
-              <a:t>  &amp; </a:t>
-            </a:r>
-            <a:r>
-              <a:rPr lang="en-US" sz="1100" dirty="0" err="1" smtClean="0">
+              <a:t>  &amp; Yara </a:t>
+            </a:r>
+            <a:r>
+              <a:rPr lang="en-US" sz="1100" dirty="0" err="1">
                 <a:solidFill>
                   <a:srgbClr val="6B7280"/>
                 </a:solidFill>
               </a:rPr>
-              <a:t>Yara</a:t>
-            </a:r>
-            <a:r>
-              <a:rPr lang="en-US" sz="1100" dirty="0" smtClean="0">
+              <a:t>Khattab</a:t>
+            </a:r>
+            <a:r>
+              <a:rPr lang="en-US" sz="1100" dirty="0">
                 <a:solidFill>
                   <a:srgbClr val="6B7280"/>
                 </a:solidFill>
               </a:rPr>
-              <a:t> </a:t>
-            </a:r>
-            <a:r>
-              <a:rPr lang="en-US" sz="1100" dirty="0" err="1" smtClean="0">
+              <a:t> | </a:t>
+            </a:r>
+            <a:r>
+              <a:rPr lang="en-US" sz="1100" dirty="0" err="1">
                 <a:solidFill>
                   <a:srgbClr val="6B7280"/>
                 </a:solidFill>
               </a:rPr>
-              <a:t>Khattab</a:t>
-            </a:r>
-            <a:r>
-              <a:rPr lang="en-US" sz="1100" dirty="0" smtClean="0">
+              <a:t>NextFlows</a:t>
+            </a:r>
+            <a:r>
+              <a:rPr lang="en-US" sz="1100" dirty="0">
                 <a:solidFill>
                   <a:srgbClr val="6B7280"/>
                 </a:solidFill>
               </a:rPr>
-              <a:t> | </a:t>
-            </a:r>
-            <a:r>
-              <a:rPr lang="en-US" sz="1100" dirty="0" err="1" smtClean="0">
-                <a:solidFill>
-                  <a:srgbClr val="6B7280"/>
-                </a:solidFill>
-              </a:rPr>
-              <a:t>NextFlows</a:t>
-            </a:r>
-            <a:r>
-              <a:rPr lang="en-US" sz="1100" dirty="0" smtClean="0">
-                <a:solidFill>
-                  <a:srgbClr val="6B7280"/>
-                </a:solidFill>
-              </a:rPr>
-              <a:t> </a:t>
-            </a:r>
-            <a:r>
-              <a:rPr lang="en-US" sz="1100" dirty="0">
-                <a:solidFill>
-                  <a:srgbClr val="6B7280"/>
-                </a:solidFill>
-              </a:rPr>
-              <a:t>Academy</a:t>
-            </a:r>
+              <a:t> Academy</a:t>
+            </a:r>
+            <a:endParaRPr lang="en-US" sz="1100" dirty="0"/>
+          </a:p>
+          <a:p>
+            <a:pPr marL="0" indent="0">
+              <a:buNone/>
+            </a:pPr>
             <a:endParaRPr lang="en-US" sz="1100" dirty="0"/>
           </a:p>
         </p:txBody>
@@ -2715,6 +2644,1478 @@
                 </a:solidFill>
               </a:rPr>
               <a:t>Task 6.3 Demo | 3/5</a:t>
+            </a:r>
+            <a:endParaRPr lang="en-US" sz="900" dirty="0"/>
+          </a:p>
+        </p:txBody>
+      </p:sp>
+    </p:spTree>
+  </p:cSld>
+  <p:clrMapOvr>
+    <a:masterClrMapping/>
+  </p:clrMapOvr>
+</p:sld>
+</file>
+
+<file path=ppt/slides/slide4.xml><?xml version="1.0" encoding="utf-8"?>
+<p:sld xmlns:a="http://schemas.openxmlformats.org/drawingml/2006/main" xmlns:r="http://schemas.openxmlformats.org/officeDocument/2006/relationships" xmlns:p="http://schemas.openxmlformats.org/presentationml/2006/main">
+  <p:cSld name="Slide 4">
+    <p:bg>
+      <p:bgPr>
+        <a:solidFill>
+          <a:srgbClr val="FFFFFF"/>
+        </a:solidFill>
+        <a:effectLst/>
+      </p:bgPr>
+    </p:bg>
+    <p:spTree>
+      <p:nvGrpSpPr>
+        <p:cNvPr id="1" name=""/>
+        <p:cNvGrpSpPr/>
+        <p:nvPr/>
+      </p:nvGrpSpPr>
+      <p:grpSpPr>
+        <a:xfrm>
+          <a:off x="0" y="0"/>
+          <a:ext cx="0" cy="0"/>
+          <a:chOff x="0" y="0"/>
+          <a:chExt cx="0" cy="0"/>
+        </a:xfrm>
+      </p:grpSpPr>
+      <p:sp>
+        <p:nvSpPr>
+          <p:cNvPr id="2" name="Text 0"/>
+          <p:cNvSpPr/>
+          <p:nvPr/>
+        </p:nvSpPr>
+        <p:spPr>
+          <a:xfrm>
+            <a:off x="502920" y="320040"/>
+            <a:ext cx="7772400" cy="411480"/>
+          </a:xfrm>
+          <a:prstGeom prst="rect">
+            <a:avLst/>
+          </a:prstGeom>
+          <a:noFill/>
+          <a:ln/>
+        </p:spPr>
+        <p:txBody>
+          <a:bodyPr wrap="square" lIns="0" tIns="0" rIns="0" bIns="0" rtlCol="0" anchor="ctr"/>
+          <a:lstStyle/>
+          <a:p>
+            <a:pPr marL="0" indent="0">
+              <a:buNone/>
+            </a:pPr>
+            <a:r>
+              <a:rPr lang="en-US" sz="2800" b="1" dirty="0">
+                <a:solidFill>
+                  <a:srgbClr val="111827"/>
+                </a:solidFill>
+              </a:rPr>
+              <a:t>Tool coverage</a:t>
+            </a:r>
+            <a:endParaRPr lang="en-US" sz="2800" dirty="0"/>
+          </a:p>
+        </p:txBody>
+      </p:sp>
+      <p:sp>
+        <p:nvSpPr>
+          <p:cNvPr id="3" name="Text 1"/>
+          <p:cNvSpPr/>
+          <p:nvPr/>
+        </p:nvSpPr>
+        <p:spPr>
+          <a:xfrm>
+            <a:off x="502920" y="822960"/>
+            <a:ext cx="8595360" cy="274320"/>
+          </a:xfrm>
+          <a:prstGeom prst="rect">
+            <a:avLst/>
+          </a:prstGeom>
+          <a:noFill/>
+          <a:ln/>
+        </p:spPr>
+        <p:txBody>
+          <a:bodyPr wrap="square" lIns="0" tIns="0" rIns="0" bIns="0" rtlCol="0" anchor="ctr"/>
+          <a:lstStyle/>
+          <a:p>
+            <a:pPr marL="0" indent="0">
+              <a:buNone/>
+            </a:pPr>
+            <a:r>
+              <a:rPr lang="en-US" sz="1400" dirty="0">
+                <a:solidFill>
+                  <a:srgbClr val="6B7280"/>
+                </a:solidFill>
+              </a:rPr>
+              <a:t>The full server exposes five real MCP tools plus two resources.</a:t>
+            </a:r>
+            <a:endParaRPr lang="en-US" sz="1400" dirty="0"/>
+          </a:p>
+        </p:txBody>
+      </p:sp>
+      <p:sp>
+        <p:nvSpPr>
+          <p:cNvPr id="4" name="Shape 2"/>
+          <p:cNvSpPr/>
+          <p:nvPr/>
+        </p:nvSpPr>
+        <p:spPr>
+          <a:xfrm>
+            <a:off x="685800" y="1325880"/>
+            <a:ext cx="10789920" cy="4160520"/>
+          </a:xfrm>
+          <a:prstGeom prst="roundRect">
+            <a:avLst>
+              <a:gd name="adj" fmla="val 1758"/>
+            </a:avLst>
+          </a:prstGeom>
+          <a:solidFill>
+            <a:srgbClr val="FFFFFF"/>
+          </a:solidFill>
+          <a:ln w="12700">
+            <a:solidFill>
+              <a:srgbClr val="E5E7EB"/>
+            </a:solidFill>
+            <a:prstDash val="solid"/>
+          </a:ln>
+        </p:spPr>
+      </p:sp>
+      <p:sp>
+        <p:nvSpPr>
+          <p:cNvPr id="5" name="Text 3"/>
+          <p:cNvSpPr/>
+          <p:nvPr/>
+        </p:nvSpPr>
+        <p:spPr>
+          <a:xfrm>
+            <a:off x="941832" y="1545336"/>
+            <a:ext cx="2011680" cy="228600"/>
+          </a:xfrm>
+          <a:prstGeom prst="rect">
+            <a:avLst/>
+          </a:prstGeom>
+          <a:noFill/>
+          <a:ln/>
+        </p:spPr>
+        <p:txBody>
+          <a:bodyPr wrap="square" lIns="0" tIns="0" rIns="0" bIns="0" rtlCol="0" anchor="ctr"/>
+          <a:lstStyle/>
+          <a:p>
+            <a:pPr marL="0" indent="0">
+              <a:buNone/>
+            </a:pPr>
+            <a:r>
+              <a:rPr lang="en-US" sz="1300" b="1" dirty="0">
+                <a:solidFill>
+                  <a:srgbClr val="111827"/>
+                </a:solidFill>
+              </a:rPr>
+              <a:t>Tool</a:t>
+            </a:r>
+            <a:endParaRPr lang="en-US" sz="1300" dirty="0"/>
+          </a:p>
+        </p:txBody>
+      </p:sp>
+      <p:sp>
+        <p:nvSpPr>
+          <p:cNvPr id="6" name="Text 4"/>
+          <p:cNvSpPr/>
+          <p:nvPr/>
+        </p:nvSpPr>
+        <p:spPr>
+          <a:xfrm>
+            <a:off x="3429000" y="1545336"/>
+            <a:ext cx="3657600" cy="228600"/>
+          </a:xfrm>
+          <a:prstGeom prst="rect">
+            <a:avLst/>
+          </a:prstGeom>
+          <a:noFill/>
+          <a:ln/>
+        </p:spPr>
+        <p:txBody>
+          <a:bodyPr wrap="square" lIns="0" tIns="0" rIns="0" bIns="0" rtlCol="0" anchor="ctr"/>
+          <a:lstStyle/>
+          <a:p>
+            <a:pPr marL="0" indent="0">
+              <a:buNone/>
+            </a:pPr>
+            <a:r>
+              <a:rPr lang="en-US" sz="1300" b="1" dirty="0">
+                <a:solidFill>
+                  <a:srgbClr val="111827"/>
+                </a:solidFill>
+              </a:rPr>
+              <a:t>Purpose</a:t>
+            </a:r>
+            <a:endParaRPr lang="en-US" sz="1300" dirty="0"/>
+          </a:p>
+        </p:txBody>
+      </p:sp>
+      <p:sp>
+        <p:nvSpPr>
+          <p:cNvPr id="7" name="Text 5"/>
+          <p:cNvSpPr/>
+          <p:nvPr/>
+        </p:nvSpPr>
+        <p:spPr>
+          <a:xfrm>
+            <a:off x="8001000" y="1545336"/>
+            <a:ext cx="2743200" cy="228600"/>
+          </a:xfrm>
+          <a:prstGeom prst="rect">
+            <a:avLst/>
+          </a:prstGeom>
+          <a:noFill/>
+          <a:ln/>
+        </p:spPr>
+        <p:txBody>
+          <a:bodyPr wrap="square" lIns="0" tIns="0" rIns="0" bIns="0" rtlCol="0" anchor="ctr"/>
+          <a:lstStyle/>
+          <a:p>
+            <a:pPr marL="0" indent="0">
+              <a:buNone/>
+            </a:pPr>
+            <a:r>
+              <a:rPr lang="en-US" sz="1300" b="1" dirty="0">
+                <a:solidFill>
+                  <a:srgbClr val="111827"/>
+                </a:solidFill>
+              </a:rPr>
+              <a:t>Main input</a:t>
+            </a:r>
+            <a:endParaRPr lang="en-US" sz="1300" dirty="0"/>
+          </a:p>
+        </p:txBody>
+      </p:sp>
+      <p:sp>
+        <p:nvSpPr>
+          <p:cNvPr id="8" name="Shape 6"/>
+          <p:cNvSpPr/>
+          <p:nvPr/>
+        </p:nvSpPr>
+        <p:spPr>
+          <a:xfrm>
+            <a:off x="914400" y="1975104"/>
+            <a:ext cx="10332720" cy="0"/>
+          </a:xfrm>
+          <a:prstGeom prst="line">
+            <a:avLst/>
+          </a:prstGeom>
+          <a:noFill/>
+          <a:ln w="7620">
+            <a:solidFill>
+              <a:srgbClr val="E5E7EB"/>
+            </a:solidFill>
+            <a:prstDash val="solid"/>
+          </a:ln>
+        </p:spPr>
+      </p:sp>
+      <p:sp>
+        <p:nvSpPr>
+          <p:cNvPr id="9" name="Text 7"/>
+          <p:cNvSpPr/>
+          <p:nvPr/>
+        </p:nvSpPr>
+        <p:spPr>
+          <a:xfrm>
+            <a:off x="941832" y="2084832"/>
+            <a:ext cx="2194560" cy="228600"/>
+          </a:xfrm>
+          <a:prstGeom prst="rect">
+            <a:avLst/>
+          </a:prstGeom>
+          <a:noFill/>
+          <a:ln/>
+        </p:spPr>
+        <p:txBody>
+          <a:bodyPr wrap="square" lIns="0" tIns="0" rIns="0" bIns="0" rtlCol="0" anchor="ctr"/>
+          <a:lstStyle/>
+          <a:p>
+            <a:pPr marL="0" indent="0">
+              <a:buNone/>
+            </a:pPr>
+            <a:r>
+              <a:rPr lang="en-US" sz="1250" b="1" dirty="0">
+                <a:solidFill>
+                  <a:srgbClr val="2563EB"/>
+                </a:solidFill>
+              </a:rPr>
+              <a:t>`search_notes`</a:t>
+            </a:r>
+            <a:endParaRPr lang="en-US" sz="1250" dirty="0"/>
+          </a:p>
+        </p:txBody>
+      </p:sp>
+      <p:sp>
+        <p:nvSpPr>
+          <p:cNvPr id="10" name="Text 8"/>
+          <p:cNvSpPr/>
+          <p:nvPr/>
+        </p:nvSpPr>
+        <p:spPr>
+          <a:xfrm>
+            <a:off x="3429000" y="2084832"/>
+            <a:ext cx="4114800" cy="228600"/>
+          </a:xfrm>
+          <a:prstGeom prst="rect">
+            <a:avLst/>
+          </a:prstGeom>
+          <a:noFill/>
+          <a:ln/>
+        </p:spPr>
+        <p:txBody>
+          <a:bodyPr wrap="square" lIns="0" tIns="0" rIns="0" bIns="0" rtlCol="0" anchor="ctr"/>
+          <a:lstStyle/>
+          <a:p>
+            <a:pPr marL="0" indent="0">
+              <a:buNone/>
+            </a:pPr>
+            <a:r>
+              <a:rPr lang="en-US" sz="1250" dirty="0">
+                <a:solidFill>
+                  <a:srgbClr val="1F2937"/>
+                </a:solidFill>
+              </a:rPr>
+              <a:t>Search local notes</a:t>
+            </a:r>
+            <a:endParaRPr lang="en-US" sz="1250" dirty="0"/>
+          </a:p>
+        </p:txBody>
+      </p:sp>
+      <p:sp>
+        <p:nvSpPr>
+          <p:cNvPr id="11" name="Text 9"/>
+          <p:cNvSpPr/>
+          <p:nvPr/>
+        </p:nvSpPr>
+        <p:spPr>
+          <a:xfrm>
+            <a:off x="8001000" y="2084832"/>
+            <a:ext cx="3017520" cy="228600"/>
+          </a:xfrm>
+          <a:prstGeom prst="rect">
+            <a:avLst/>
+          </a:prstGeom>
+          <a:noFill/>
+          <a:ln/>
+        </p:spPr>
+        <p:txBody>
+          <a:bodyPr wrap="square" lIns="0" tIns="0" rIns="0" bIns="0" rtlCol="0" anchor="ctr"/>
+          <a:lstStyle/>
+          <a:p>
+            <a:pPr marL="0" indent="0">
+              <a:buNone/>
+            </a:pPr>
+            <a:r>
+              <a:rPr lang="en-US" sz="1250" dirty="0">
+                <a:solidFill>
+                  <a:srgbClr val="1F2937"/>
+                </a:solidFill>
+              </a:rPr>
+              <a:t>query, limit</a:t>
+            </a:r>
+            <a:endParaRPr lang="en-US" sz="1250" dirty="0"/>
+          </a:p>
+        </p:txBody>
+      </p:sp>
+      <p:sp>
+        <p:nvSpPr>
+          <p:cNvPr id="12" name="Shape 10"/>
+          <p:cNvSpPr/>
+          <p:nvPr/>
+        </p:nvSpPr>
+        <p:spPr>
+          <a:xfrm>
+            <a:off x="914400" y="2606040"/>
+            <a:ext cx="10332720" cy="0"/>
+          </a:xfrm>
+          <a:prstGeom prst="line">
+            <a:avLst/>
+          </a:prstGeom>
+          <a:noFill/>
+          <a:ln w="7620">
+            <a:solidFill>
+              <a:srgbClr val="E5E7EB"/>
+            </a:solidFill>
+            <a:prstDash val="solid"/>
+          </a:ln>
+        </p:spPr>
+      </p:sp>
+      <p:sp>
+        <p:nvSpPr>
+          <p:cNvPr id="13" name="Text 11"/>
+          <p:cNvSpPr/>
+          <p:nvPr/>
+        </p:nvSpPr>
+        <p:spPr>
+          <a:xfrm>
+            <a:off x="941832" y="2715768"/>
+            <a:ext cx="2194560" cy="228600"/>
+          </a:xfrm>
+          <a:prstGeom prst="rect">
+            <a:avLst/>
+          </a:prstGeom>
+          <a:noFill/>
+          <a:ln/>
+        </p:spPr>
+        <p:txBody>
+          <a:bodyPr wrap="square" lIns="0" tIns="0" rIns="0" bIns="0" rtlCol="0" anchor="ctr"/>
+          <a:lstStyle/>
+          <a:p>
+            <a:pPr marL="0" indent="0">
+              <a:buNone/>
+            </a:pPr>
+            <a:r>
+              <a:rPr lang="en-US" sz="1250" b="1" dirty="0">
+                <a:solidFill>
+                  <a:srgbClr val="2563EB"/>
+                </a:solidFill>
+              </a:rPr>
+              <a:t>`search_faqs`</a:t>
+            </a:r>
+            <a:endParaRPr lang="en-US" sz="1250" dirty="0"/>
+          </a:p>
+        </p:txBody>
+      </p:sp>
+      <p:sp>
+        <p:nvSpPr>
+          <p:cNvPr id="14" name="Text 12"/>
+          <p:cNvSpPr/>
+          <p:nvPr/>
+        </p:nvSpPr>
+        <p:spPr>
+          <a:xfrm>
+            <a:off x="3429000" y="2715768"/>
+            <a:ext cx="4114800" cy="228600"/>
+          </a:xfrm>
+          <a:prstGeom prst="rect">
+            <a:avLst/>
+          </a:prstGeom>
+          <a:noFill/>
+          <a:ln/>
+        </p:spPr>
+        <p:txBody>
+          <a:bodyPr wrap="square" lIns="0" tIns="0" rIns="0" bIns="0" rtlCol="0" anchor="ctr"/>
+          <a:lstStyle/>
+          <a:p>
+            <a:pPr marL="0" indent="0">
+              <a:buNone/>
+            </a:pPr>
+            <a:r>
+              <a:rPr lang="en-US" sz="1250" dirty="0">
+                <a:solidFill>
+                  <a:srgbClr val="1F2937"/>
+                </a:solidFill>
+              </a:rPr>
+              <a:t>Search FAQ entries</a:t>
+            </a:r>
+            <a:endParaRPr lang="en-US" sz="1250" dirty="0"/>
+          </a:p>
+        </p:txBody>
+      </p:sp>
+      <p:sp>
+        <p:nvSpPr>
+          <p:cNvPr id="15" name="Text 13"/>
+          <p:cNvSpPr/>
+          <p:nvPr/>
+        </p:nvSpPr>
+        <p:spPr>
+          <a:xfrm>
+            <a:off x="8001000" y="2715768"/>
+            <a:ext cx="3017520" cy="228600"/>
+          </a:xfrm>
+          <a:prstGeom prst="rect">
+            <a:avLst/>
+          </a:prstGeom>
+          <a:noFill/>
+          <a:ln/>
+        </p:spPr>
+        <p:txBody>
+          <a:bodyPr wrap="square" lIns="0" tIns="0" rIns="0" bIns="0" rtlCol="0" anchor="ctr"/>
+          <a:lstStyle/>
+          <a:p>
+            <a:pPr marL="0" indent="0">
+              <a:buNone/>
+            </a:pPr>
+            <a:r>
+              <a:rPr lang="en-US" sz="1250" dirty="0">
+                <a:solidFill>
+                  <a:srgbClr val="1F2937"/>
+                </a:solidFill>
+              </a:rPr>
+              <a:t>query, limit</a:t>
+            </a:r>
+            <a:endParaRPr lang="en-US" sz="1250" dirty="0"/>
+          </a:p>
+        </p:txBody>
+      </p:sp>
+      <p:sp>
+        <p:nvSpPr>
+          <p:cNvPr id="16" name="Shape 14"/>
+          <p:cNvSpPr/>
+          <p:nvPr/>
+        </p:nvSpPr>
+        <p:spPr>
+          <a:xfrm>
+            <a:off x="914400" y="3236976"/>
+            <a:ext cx="10332720" cy="0"/>
+          </a:xfrm>
+          <a:prstGeom prst="line">
+            <a:avLst/>
+          </a:prstGeom>
+          <a:noFill/>
+          <a:ln w="7620">
+            <a:solidFill>
+              <a:srgbClr val="E5E7EB"/>
+            </a:solidFill>
+            <a:prstDash val="solid"/>
+          </a:ln>
+        </p:spPr>
+      </p:sp>
+      <p:sp>
+        <p:nvSpPr>
+          <p:cNvPr id="17" name="Text 15"/>
+          <p:cNvSpPr/>
+          <p:nvPr/>
+        </p:nvSpPr>
+        <p:spPr>
+          <a:xfrm>
+            <a:off x="941832" y="3346704"/>
+            <a:ext cx="2194560" cy="228600"/>
+          </a:xfrm>
+          <a:prstGeom prst="rect">
+            <a:avLst/>
+          </a:prstGeom>
+          <a:noFill/>
+          <a:ln/>
+        </p:spPr>
+        <p:txBody>
+          <a:bodyPr wrap="square" lIns="0" tIns="0" rIns="0" bIns="0" rtlCol="0" anchor="ctr"/>
+          <a:lstStyle/>
+          <a:p>
+            <a:pPr marL="0" indent="0">
+              <a:buNone/>
+            </a:pPr>
+            <a:r>
+              <a:rPr lang="en-US" sz="1250" b="1" dirty="0">
+                <a:solidFill>
+                  <a:srgbClr val="2563EB"/>
+                </a:solidFill>
+              </a:rPr>
+              <a:t>`get_note`</a:t>
+            </a:r>
+            <a:endParaRPr lang="en-US" sz="1250" dirty="0"/>
+          </a:p>
+        </p:txBody>
+      </p:sp>
+      <p:sp>
+        <p:nvSpPr>
+          <p:cNvPr id="18" name="Text 16"/>
+          <p:cNvSpPr/>
+          <p:nvPr/>
+        </p:nvSpPr>
+        <p:spPr>
+          <a:xfrm>
+            <a:off x="3429000" y="3346704"/>
+            <a:ext cx="4114800" cy="228600"/>
+          </a:xfrm>
+          <a:prstGeom prst="rect">
+            <a:avLst/>
+          </a:prstGeom>
+          <a:noFill/>
+          <a:ln/>
+        </p:spPr>
+        <p:txBody>
+          <a:bodyPr wrap="square" lIns="0" tIns="0" rIns="0" bIns="0" rtlCol="0" anchor="ctr"/>
+          <a:lstStyle/>
+          <a:p>
+            <a:pPr marL="0" indent="0">
+              <a:buNone/>
+            </a:pPr>
+            <a:r>
+              <a:rPr lang="en-US" sz="1250" dirty="0">
+                <a:solidFill>
+                  <a:srgbClr val="1F2937"/>
+                </a:solidFill>
+              </a:rPr>
+              <a:t>Retrieve one note</a:t>
+            </a:r>
+            <a:endParaRPr lang="en-US" sz="1250" dirty="0"/>
+          </a:p>
+        </p:txBody>
+      </p:sp>
+      <p:sp>
+        <p:nvSpPr>
+          <p:cNvPr id="19" name="Text 17"/>
+          <p:cNvSpPr/>
+          <p:nvPr/>
+        </p:nvSpPr>
+        <p:spPr>
+          <a:xfrm>
+            <a:off x="8001000" y="3346704"/>
+            <a:ext cx="3017520" cy="228600"/>
+          </a:xfrm>
+          <a:prstGeom prst="rect">
+            <a:avLst/>
+          </a:prstGeom>
+          <a:noFill/>
+          <a:ln/>
+        </p:spPr>
+        <p:txBody>
+          <a:bodyPr wrap="square" lIns="0" tIns="0" rIns="0" bIns="0" rtlCol="0" anchor="ctr"/>
+          <a:lstStyle/>
+          <a:p>
+            <a:pPr marL="0" indent="0">
+              <a:buNone/>
+            </a:pPr>
+            <a:r>
+              <a:rPr lang="en-US" sz="1250" dirty="0">
+                <a:solidFill>
+                  <a:srgbClr val="1F2937"/>
+                </a:solidFill>
+              </a:rPr>
+              <a:t>note_id</a:t>
+            </a:r>
+            <a:endParaRPr lang="en-US" sz="1250" dirty="0"/>
+          </a:p>
+        </p:txBody>
+      </p:sp>
+      <p:sp>
+        <p:nvSpPr>
+          <p:cNvPr id="20" name="Shape 18"/>
+          <p:cNvSpPr/>
+          <p:nvPr/>
+        </p:nvSpPr>
+        <p:spPr>
+          <a:xfrm>
+            <a:off x="914400" y="3867912"/>
+            <a:ext cx="10332720" cy="0"/>
+          </a:xfrm>
+          <a:prstGeom prst="line">
+            <a:avLst/>
+          </a:prstGeom>
+          <a:noFill/>
+          <a:ln w="7620">
+            <a:solidFill>
+              <a:srgbClr val="E5E7EB"/>
+            </a:solidFill>
+            <a:prstDash val="solid"/>
+          </a:ln>
+        </p:spPr>
+      </p:sp>
+      <p:sp>
+        <p:nvSpPr>
+          <p:cNvPr id="21" name="Text 19"/>
+          <p:cNvSpPr/>
+          <p:nvPr/>
+        </p:nvSpPr>
+        <p:spPr>
+          <a:xfrm>
+            <a:off x="941832" y="3977640"/>
+            <a:ext cx="2194560" cy="228600"/>
+          </a:xfrm>
+          <a:prstGeom prst="rect">
+            <a:avLst/>
+          </a:prstGeom>
+          <a:noFill/>
+          <a:ln/>
+        </p:spPr>
+        <p:txBody>
+          <a:bodyPr wrap="square" lIns="0" tIns="0" rIns="0" bIns="0" rtlCol="0" anchor="ctr"/>
+          <a:lstStyle/>
+          <a:p>
+            <a:pPr marL="0" indent="0">
+              <a:buNone/>
+            </a:pPr>
+            <a:r>
+              <a:rPr lang="en-US" sz="1250" b="1" dirty="0">
+                <a:solidFill>
+                  <a:srgbClr val="2563EB"/>
+                </a:solidFill>
+              </a:rPr>
+              <a:t>`list_notes`</a:t>
+            </a:r>
+            <a:endParaRPr lang="en-US" sz="1250" dirty="0"/>
+          </a:p>
+        </p:txBody>
+      </p:sp>
+      <p:sp>
+        <p:nvSpPr>
+          <p:cNvPr id="22" name="Text 20"/>
+          <p:cNvSpPr/>
+          <p:nvPr/>
+        </p:nvSpPr>
+        <p:spPr>
+          <a:xfrm>
+            <a:off x="3429000" y="3977640"/>
+            <a:ext cx="4114800" cy="228600"/>
+          </a:xfrm>
+          <a:prstGeom prst="rect">
+            <a:avLst/>
+          </a:prstGeom>
+          <a:noFill/>
+          <a:ln/>
+        </p:spPr>
+        <p:txBody>
+          <a:bodyPr wrap="square" lIns="0" tIns="0" rIns="0" bIns="0" rtlCol="0" anchor="ctr"/>
+          <a:lstStyle/>
+          <a:p>
+            <a:pPr marL="0" indent="0">
+              <a:buNone/>
+            </a:pPr>
+            <a:r>
+              <a:rPr lang="en-US" sz="1250" dirty="0">
+                <a:solidFill>
+                  <a:srgbClr val="1F2937"/>
+                </a:solidFill>
+              </a:rPr>
+              <a:t>Browse notes</a:t>
+            </a:r>
+            <a:endParaRPr lang="en-US" sz="1250" dirty="0"/>
+          </a:p>
+        </p:txBody>
+      </p:sp>
+      <p:sp>
+        <p:nvSpPr>
+          <p:cNvPr id="23" name="Text 21"/>
+          <p:cNvSpPr/>
+          <p:nvPr/>
+        </p:nvSpPr>
+        <p:spPr>
+          <a:xfrm>
+            <a:off x="8001000" y="3977640"/>
+            <a:ext cx="3017520" cy="228600"/>
+          </a:xfrm>
+          <a:prstGeom prst="rect">
+            <a:avLst/>
+          </a:prstGeom>
+          <a:noFill/>
+          <a:ln/>
+        </p:spPr>
+        <p:txBody>
+          <a:bodyPr wrap="square" lIns="0" tIns="0" rIns="0" bIns="0" rtlCol="0" anchor="ctr"/>
+          <a:lstStyle/>
+          <a:p>
+            <a:pPr marL="0" indent="0">
+              <a:buNone/>
+            </a:pPr>
+            <a:r>
+              <a:rPr lang="en-US" sz="1250" dirty="0">
+                <a:solidFill>
+                  <a:srgbClr val="1F2937"/>
+                </a:solidFill>
+              </a:rPr>
+              <a:t>tag, limit</a:t>
+            </a:r>
+            <a:endParaRPr lang="en-US" sz="1250" dirty="0"/>
+          </a:p>
+        </p:txBody>
+      </p:sp>
+      <p:sp>
+        <p:nvSpPr>
+          <p:cNvPr id="24" name="Shape 22"/>
+          <p:cNvSpPr/>
+          <p:nvPr/>
+        </p:nvSpPr>
+        <p:spPr>
+          <a:xfrm>
+            <a:off x="914400" y="4498848"/>
+            <a:ext cx="10332720" cy="0"/>
+          </a:xfrm>
+          <a:prstGeom prst="line">
+            <a:avLst/>
+          </a:prstGeom>
+          <a:noFill/>
+          <a:ln w="7620">
+            <a:solidFill>
+              <a:srgbClr val="E5E7EB"/>
+            </a:solidFill>
+            <a:prstDash val="solid"/>
+          </a:ln>
+        </p:spPr>
+      </p:sp>
+      <p:sp>
+        <p:nvSpPr>
+          <p:cNvPr id="25" name="Text 23"/>
+          <p:cNvSpPr/>
+          <p:nvPr/>
+        </p:nvSpPr>
+        <p:spPr>
+          <a:xfrm>
+            <a:off x="941832" y="4608576"/>
+            <a:ext cx="2194560" cy="228600"/>
+          </a:xfrm>
+          <a:prstGeom prst="rect">
+            <a:avLst/>
+          </a:prstGeom>
+          <a:noFill/>
+          <a:ln/>
+        </p:spPr>
+        <p:txBody>
+          <a:bodyPr wrap="square" lIns="0" tIns="0" rIns="0" bIns="0" rtlCol="0" anchor="ctr"/>
+          <a:lstStyle/>
+          <a:p>
+            <a:pPr marL="0" indent="0">
+              <a:buNone/>
+            </a:pPr>
+            <a:r>
+              <a:rPr lang="en-US" sz="1250" b="1" dirty="0">
+                <a:solidFill>
+                  <a:srgbClr val="2563EB"/>
+                </a:solidFill>
+              </a:rPr>
+              <a:t>`add_note`</a:t>
+            </a:r>
+            <a:endParaRPr lang="en-US" sz="1250" dirty="0"/>
+          </a:p>
+        </p:txBody>
+      </p:sp>
+      <p:sp>
+        <p:nvSpPr>
+          <p:cNvPr id="26" name="Text 24"/>
+          <p:cNvSpPr/>
+          <p:nvPr/>
+        </p:nvSpPr>
+        <p:spPr>
+          <a:xfrm>
+            <a:off x="3429000" y="4608576"/>
+            <a:ext cx="4114800" cy="228600"/>
+          </a:xfrm>
+          <a:prstGeom prst="rect">
+            <a:avLst/>
+          </a:prstGeom>
+          <a:noFill/>
+          <a:ln/>
+        </p:spPr>
+        <p:txBody>
+          <a:bodyPr wrap="square" lIns="0" tIns="0" rIns="0" bIns="0" rtlCol="0" anchor="ctr"/>
+          <a:lstStyle/>
+          <a:p>
+            <a:pPr marL="0" indent="0">
+              <a:buNone/>
+            </a:pPr>
+            <a:r>
+              <a:rPr lang="en-US" sz="1250" dirty="0">
+                <a:solidFill>
+                  <a:srgbClr val="1F2937"/>
+                </a:solidFill>
+              </a:rPr>
+              <a:t>Safely add a local note</a:t>
+            </a:r>
+            <a:endParaRPr lang="en-US" sz="1250" dirty="0"/>
+          </a:p>
+        </p:txBody>
+      </p:sp>
+      <p:sp>
+        <p:nvSpPr>
+          <p:cNvPr id="27" name="Text 25"/>
+          <p:cNvSpPr/>
+          <p:nvPr/>
+        </p:nvSpPr>
+        <p:spPr>
+          <a:xfrm>
+            <a:off x="8001000" y="4608576"/>
+            <a:ext cx="3017520" cy="228600"/>
+          </a:xfrm>
+          <a:prstGeom prst="rect">
+            <a:avLst/>
+          </a:prstGeom>
+          <a:noFill/>
+          <a:ln/>
+        </p:spPr>
+        <p:txBody>
+          <a:bodyPr wrap="square" lIns="0" tIns="0" rIns="0" bIns="0" rtlCol="0" anchor="ctr"/>
+          <a:lstStyle/>
+          <a:p>
+            <a:pPr marL="0" indent="0">
+              <a:buNone/>
+            </a:pPr>
+            <a:r>
+              <a:rPr lang="en-US" sz="1250" dirty="0">
+                <a:solidFill>
+                  <a:srgbClr val="1F2937"/>
+                </a:solidFill>
+              </a:rPr>
+              <a:t>title, content, tags</a:t>
+            </a:r>
+            <a:endParaRPr lang="en-US" sz="1250" dirty="0"/>
+          </a:p>
+        </p:txBody>
+      </p:sp>
+      <p:sp>
+        <p:nvSpPr>
+          <p:cNvPr id="28" name="Shape 26"/>
+          <p:cNvSpPr/>
+          <p:nvPr/>
+        </p:nvSpPr>
+        <p:spPr>
+          <a:xfrm>
+            <a:off x="868680" y="5806440"/>
+            <a:ext cx="1920240" cy="365760"/>
+          </a:xfrm>
+          <a:prstGeom prst="roundRect">
+            <a:avLst>
+              <a:gd name="adj" fmla="val 20000"/>
+            </a:avLst>
+          </a:prstGeom>
+          <a:solidFill>
+            <a:srgbClr val="DCFCE7"/>
+          </a:solidFill>
+          <a:ln w="12700">
+            <a:solidFill>
+              <a:srgbClr val="DCFCE7"/>
+            </a:solidFill>
+            <a:prstDash val="solid"/>
+          </a:ln>
+        </p:spPr>
+      </p:sp>
+      <p:sp>
+        <p:nvSpPr>
+          <p:cNvPr id="29" name="Text 27"/>
+          <p:cNvSpPr/>
+          <p:nvPr/>
+        </p:nvSpPr>
+        <p:spPr>
+          <a:xfrm>
+            <a:off x="960120" y="5902452"/>
+            <a:ext cx="1737360" cy="146304"/>
+          </a:xfrm>
+          <a:prstGeom prst="rect">
+            <a:avLst/>
+          </a:prstGeom>
+          <a:noFill/>
+          <a:ln/>
+        </p:spPr>
+        <p:txBody>
+          <a:bodyPr wrap="square" lIns="0" tIns="0" rIns="0" bIns="0" rtlCol="0" anchor="ctr"/>
+          <a:lstStyle/>
+          <a:p>
+            <a:pPr marL="0" indent="0" algn="ctr">
+              <a:buNone/>
+            </a:pPr>
+            <a:r>
+              <a:rPr lang="en-US" sz="1050" b="1" dirty="0">
+                <a:solidFill>
+                  <a:srgbClr val="111827"/>
+                </a:solidFill>
+              </a:rPr>
+              <a:t>Live demo: search_notes</a:t>
+            </a:r>
+            <a:endParaRPr lang="en-US" sz="1050" dirty="0"/>
+          </a:p>
+        </p:txBody>
+      </p:sp>
+      <p:sp>
+        <p:nvSpPr>
+          <p:cNvPr id="30" name="Shape 28"/>
+          <p:cNvSpPr/>
+          <p:nvPr/>
+        </p:nvSpPr>
+        <p:spPr>
+          <a:xfrm>
+            <a:off x="3017520" y="5806440"/>
+            <a:ext cx="1691640" cy="365760"/>
+          </a:xfrm>
+          <a:prstGeom prst="roundRect">
+            <a:avLst>
+              <a:gd name="adj" fmla="val 20000"/>
+            </a:avLst>
+          </a:prstGeom>
+          <a:solidFill>
+            <a:srgbClr val="DCFCE7"/>
+          </a:solidFill>
+          <a:ln w="12700">
+            <a:solidFill>
+              <a:srgbClr val="DCFCE7"/>
+            </a:solidFill>
+            <a:prstDash val="solid"/>
+          </a:ln>
+        </p:spPr>
+      </p:sp>
+      <p:sp>
+        <p:nvSpPr>
+          <p:cNvPr id="31" name="Text 29"/>
+          <p:cNvSpPr/>
+          <p:nvPr/>
+        </p:nvSpPr>
+        <p:spPr>
+          <a:xfrm>
+            <a:off x="3108960" y="5902452"/>
+            <a:ext cx="1508760" cy="146304"/>
+          </a:xfrm>
+          <a:prstGeom prst="rect">
+            <a:avLst/>
+          </a:prstGeom>
+          <a:noFill/>
+          <a:ln/>
+        </p:spPr>
+        <p:txBody>
+          <a:bodyPr wrap="square" lIns="0" tIns="0" rIns="0" bIns="0" rtlCol="0" anchor="ctr"/>
+          <a:lstStyle/>
+          <a:p>
+            <a:pPr marL="0" indent="0" algn="ctr">
+              <a:buNone/>
+            </a:pPr>
+            <a:r>
+              <a:rPr lang="en-US" sz="1050" b="1" dirty="0">
+                <a:solidFill>
+                  <a:srgbClr val="111827"/>
+                </a:solidFill>
+              </a:rPr>
+              <a:t>Live demo: get_note</a:t>
+            </a:r>
+            <a:endParaRPr lang="en-US" sz="1050" dirty="0"/>
+          </a:p>
+        </p:txBody>
+      </p:sp>
+      <p:sp>
+        <p:nvSpPr>
+          <p:cNvPr id="32" name="Text 30"/>
+          <p:cNvSpPr/>
+          <p:nvPr/>
+        </p:nvSpPr>
+        <p:spPr>
+          <a:xfrm>
+            <a:off x="502920" y="6455664"/>
+            <a:ext cx="2743200" cy="182880"/>
+          </a:xfrm>
+          <a:prstGeom prst="rect">
+            <a:avLst/>
+          </a:prstGeom>
+          <a:noFill/>
+          <a:ln/>
+        </p:spPr>
+        <p:txBody>
+          <a:bodyPr wrap="square" rtlCol="0" anchor="ctr"/>
+          <a:lstStyle/>
+          <a:p>
+            <a:pPr marL="0" indent="0">
+              <a:buNone/>
+            </a:pPr>
+            <a:r>
+              <a:rPr lang="en-US" sz="900" dirty="0">
+                <a:solidFill>
+                  <a:srgbClr val="6B7280"/>
+                </a:solidFill>
+              </a:rPr>
+              <a:t>Task 6.3 Demo | 4/5</a:t>
+            </a:r>
+            <a:endParaRPr lang="en-US" sz="900" dirty="0"/>
+          </a:p>
+        </p:txBody>
+      </p:sp>
+    </p:spTree>
+  </p:cSld>
+  <p:clrMapOvr>
+    <a:masterClrMapping/>
+  </p:clrMapOvr>
+</p:sld>
+</file>
+
+<file path=ppt/slides/slide5.xml><?xml version="1.0" encoding="utf-8"?>
+<p:sld xmlns:a="http://schemas.openxmlformats.org/drawingml/2006/main" xmlns:r="http://schemas.openxmlformats.org/officeDocument/2006/relationships" xmlns:p="http://schemas.openxmlformats.org/presentationml/2006/main">
+  <p:cSld name="Slide 5">
+    <p:bg>
+      <p:bgPr>
+        <a:solidFill>
+          <a:srgbClr val="F8FAFC"/>
+        </a:solidFill>
+        <a:effectLst/>
+      </p:bgPr>
+    </p:bg>
+    <p:spTree>
+      <p:nvGrpSpPr>
+        <p:cNvPr id="1" name=""/>
+        <p:cNvGrpSpPr/>
+        <p:nvPr/>
+      </p:nvGrpSpPr>
+      <p:grpSpPr>
+        <a:xfrm>
+          <a:off x="0" y="0"/>
+          <a:ext cx="0" cy="0"/>
+          <a:chOff x="0" y="0"/>
+          <a:chExt cx="0" cy="0"/>
+        </a:xfrm>
+      </p:grpSpPr>
+      <p:sp>
+        <p:nvSpPr>
+          <p:cNvPr id="2" name="Text 0"/>
+          <p:cNvSpPr/>
+          <p:nvPr/>
+        </p:nvSpPr>
+        <p:spPr>
+          <a:xfrm>
+            <a:off x="502920" y="320040"/>
+            <a:ext cx="7772400" cy="411480"/>
+          </a:xfrm>
+          <a:prstGeom prst="rect">
+            <a:avLst/>
+          </a:prstGeom>
+          <a:noFill/>
+          <a:ln/>
+        </p:spPr>
+        <p:txBody>
+          <a:bodyPr wrap="square" lIns="0" tIns="0" rIns="0" bIns="0" rtlCol="0" anchor="ctr"/>
+          <a:lstStyle/>
+          <a:p>
+            <a:pPr marL="0" indent="0">
+              <a:buNone/>
+            </a:pPr>
+            <a:r>
+              <a:rPr lang="en-US" sz="2800" b="1" dirty="0">
+                <a:solidFill>
+                  <a:srgbClr val="111827"/>
+                </a:solidFill>
+              </a:rPr>
+              <a:t>Next steps &amp; backup plan</a:t>
+            </a:r>
+            <a:endParaRPr lang="en-US" sz="2800" dirty="0"/>
+          </a:p>
+        </p:txBody>
+      </p:sp>
+      <p:sp>
+        <p:nvSpPr>
+          <p:cNvPr id="3" name="Text 1"/>
+          <p:cNvSpPr/>
+          <p:nvPr/>
+        </p:nvSpPr>
+        <p:spPr>
+          <a:xfrm>
+            <a:off x="502920" y="822960"/>
+            <a:ext cx="8595360" cy="274320"/>
+          </a:xfrm>
+          <a:prstGeom prst="rect">
+            <a:avLst/>
+          </a:prstGeom>
+          <a:noFill/>
+          <a:ln/>
+        </p:spPr>
+        <p:txBody>
+          <a:bodyPr wrap="square" lIns="0" tIns="0" rIns="0" bIns="0" rtlCol="0" anchor="ctr"/>
+          <a:lstStyle/>
+          <a:p>
+            <a:pPr marL="0" indent="0">
+              <a:buNone/>
+            </a:pPr>
+            <a:r>
+              <a:rPr lang="en-US" sz="1400" dirty="0">
+                <a:solidFill>
+                  <a:srgbClr val="6B7280"/>
+                </a:solidFill>
+              </a:rPr>
+              <a:t>Keep the demo timeboxed and switch to offline evidence if the live setup fails.</a:t>
+            </a:r>
+            <a:endParaRPr lang="en-US" sz="1400" dirty="0"/>
+          </a:p>
+        </p:txBody>
+      </p:sp>
+      <p:sp>
+        <p:nvSpPr>
+          <p:cNvPr id="4" name="Shape 2"/>
+          <p:cNvSpPr/>
+          <p:nvPr/>
+        </p:nvSpPr>
+        <p:spPr>
+          <a:xfrm>
+            <a:off x="685800" y="1417320"/>
+            <a:ext cx="4937760" cy="3200400"/>
+          </a:xfrm>
+          <a:prstGeom prst="roundRect">
+            <a:avLst>
+              <a:gd name="adj" fmla="val 2571"/>
+            </a:avLst>
+          </a:prstGeom>
+          <a:solidFill>
+            <a:srgbClr val="FFFFFF"/>
+          </a:solidFill>
+          <a:ln w="12700">
+            <a:solidFill>
+              <a:srgbClr val="E5E7EB"/>
+            </a:solidFill>
+            <a:prstDash val="solid"/>
+          </a:ln>
+        </p:spPr>
+      </p:sp>
+      <p:sp>
+        <p:nvSpPr>
+          <p:cNvPr id="5" name="Text 3"/>
+          <p:cNvSpPr/>
+          <p:nvPr/>
+        </p:nvSpPr>
+        <p:spPr>
+          <a:xfrm>
+            <a:off x="886968" y="1600200"/>
+            <a:ext cx="4535424" cy="237744"/>
+          </a:xfrm>
+          <a:prstGeom prst="rect">
+            <a:avLst/>
+          </a:prstGeom>
+          <a:noFill/>
+          <a:ln/>
+        </p:spPr>
+        <p:txBody>
+          <a:bodyPr wrap="square" lIns="0" tIns="0" rIns="0" bIns="0" rtlCol="0" anchor="ctr"/>
+          <a:lstStyle/>
+          <a:p>
+            <a:pPr marL="0" indent="0">
+              <a:buNone/>
+            </a:pPr>
+            <a:r>
+              <a:rPr lang="en-US" sz="1500" b="1" dirty="0">
+                <a:solidFill>
+                  <a:srgbClr val="111827"/>
+                </a:solidFill>
+              </a:rPr>
+              <a:t>Next steps</a:t>
+            </a:r>
+            <a:endParaRPr lang="en-US" sz="1500" dirty="0"/>
+          </a:p>
+        </p:txBody>
+      </p:sp>
+      <p:sp>
+        <p:nvSpPr>
+          <p:cNvPr id="6" name="Text 4"/>
+          <p:cNvSpPr/>
+          <p:nvPr/>
+        </p:nvSpPr>
+        <p:spPr>
+          <a:xfrm>
+            <a:off x="886968" y="1984248"/>
+            <a:ext cx="4535424" cy="2468880"/>
+          </a:xfrm>
+          <a:prstGeom prst="rect">
+            <a:avLst/>
+          </a:prstGeom>
+          <a:noFill/>
+          <a:ln/>
+        </p:spPr>
+        <p:txBody>
+          <a:bodyPr wrap="square" lIns="0" tIns="0" rIns="0" bIns="0" rtlCol="0" anchor="ctr">
+            <a:normAutofit/>
+          </a:bodyPr>
+          <a:lstStyle/>
+          <a:p>
+            <a:pPr marL="0" indent="0">
+              <a:buNone/>
+            </a:pPr>
+            <a:r>
+              <a:rPr lang="en-US" sz="1180" dirty="0">
+                <a:solidFill>
+                  <a:srgbClr val="1F2937"/>
+                </a:solidFill>
+              </a:rPr>
+              <a:t>Add a short recorded walkthrough, expand fixture examples, and improve common prompt examples while keeping the server offline and focused.</a:t>
+            </a:r>
+            <a:endParaRPr lang="en-US" sz="1180" dirty="0"/>
+          </a:p>
+        </p:txBody>
+      </p:sp>
+      <p:sp>
+        <p:nvSpPr>
+          <p:cNvPr id="7" name="Shape 5"/>
+          <p:cNvSpPr/>
+          <p:nvPr/>
+        </p:nvSpPr>
+        <p:spPr>
+          <a:xfrm>
+            <a:off x="6400800" y="1417320"/>
+            <a:ext cx="4937760" cy="3200400"/>
+          </a:xfrm>
+          <a:prstGeom prst="roundRect">
+            <a:avLst>
+              <a:gd name="adj" fmla="val 2571"/>
+            </a:avLst>
+          </a:prstGeom>
+          <a:solidFill>
+            <a:srgbClr val="FFFFFF"/>
+          </a:solidFill>
+          <a:ln w="12700">
+            <a:solidFill>
+              <a:srgbClr val="E5E7EB"/>
+            </a:solidFill>
+            <a:prstDash val="solid"/>
+          </a:ln>
+        </p:spPr>
+      </p:sp>
+      <p:sp>
+        <p:nvSpPr>
+          <p:cNvPr id="8" name="Text 6"/>
+          <p:cNvSpPr/>
+          <p:nvPr/>
+        </p:nvSpPr>
+        <p:spPr>
+          <a:xfrm>
+            <a:off x="6601968" y="1600200"/>
+            <a:ext cx="4535424" cy="237744"/>
+          </a:xfrm>
+          <a:prstGeom prst="rect">
+            <a:avLst/>
+          </a:prstGeom>
+          <a:noFill/>
+          <a:ln/>
+        </p:spPr>
+        <p:txBody>
+          <a:bodyPr wrap="square" lIns="0" tIns="0" rIns="0" bIns="0" rtlCol="0" anchor="ctr"/>
+          <a:lstStyle/>
+          <a:p>
+            <a:pPr marL="0" indent="0">
+              <a:buNone/>
+            </a:pPr>
+            <a:r>
+              <a:rPr lang="en-US" sz="1500" b="1" dirty="0">
+                <a:solidFill>
+                  <a:srgbClr val="111827"/>
+                </a:solidFill>
+              </a:rPr>
+              <a:t>Backup plan</a:t>
+            </a:r>
+            <a:endParaRPr lang="en-US" sz="1500" dirty="0"/>
+          </a:p>
+        </p:txBody>
+      </p:sp>
+      <p:sp>
+        <p:nvSpPr>
+          <p:cNvPr id="9" name="Text 7"/>
+          <p:cNvSpPr/>
+          <p:nvPr/>
+        </p:nvSpPr>
+        <p:spPr>
+          <a:xfrm>
+            <a:off x="6601968" y="1984248"/>
+            <a:ext cx="4535424" cy="2468880"/>
+          </a:xfrm>
+          <a:prstGeom prst="rect">
+            <a:avLst/>
+          </a:prstGeom>
+          <a:noFill/>
+          <a:ln/>
+        </p:spPr>
+        <p:txBody>
+          <a:bodyPr wrap="square" lIns="0" tIns="0" rIns="0" bIns="0" rtlCol="0" anchor="ctr">
+            <a:normAutofit/>
+          </a:bodyPr>
+          <a:lstStyle/>
+          <a:p>
+            <a:pPr marL="0" indent="0">
+              <a:buNone/>
+            </a:pPr>
+            <a:r>
+              <a:rPr lang="en-US" sz="1180" dirty="0">
+                <a:solidFill>
+                  <a:srgbClr val="1F2937"/>
+                </a:solidFill>
+              </a:rPr>
+              <a:t>If Wi-Fi fails, use the installed local clone and MCP Inspector. If the host fails, show fresh-clone screenshots from v1.0.0.</a:t>
+            </a:r>
+            <a:endParaRPr lang="en-US" sz="1180" dirty="0"/>
+          </a:p>
+        </p:txBody>
+      </p:sp>
+      <p:sp>
+        <p:nvSpPr>
+          <p:cNvPr id="10" name="Text 8"/>
+          <p:cNvSpPr/>
+          <p:nvPr/>
+        </p:nvSpPr>
+        <p:spPr>
+          <a:xfrm>
+            <a:off x="685800" y="5486400"/>
+            <a:ext cx="4754880" cy="365760"/>
+          </a:xfrm>
+          <a:prstGeom prst="rect">
+            <a:avLst/>
+          </a:prstGeom>
+          <a:noFill/>
+          <a:ln/>
+        </p:spPr>
+        <p:txBody>
+          <a:bodyPr wrap="square" lIns="0" tIns="0" rIns="0" bIns="0" rtlCol="0" anchor="ctr"/>
+          <a:lstStyle/>
+          <a:p>
+            <a:pPr marL="0" indent="0">
+              <a:buNone/>
+            </a:pPr>
+            <a:r>
+              <a:rPr lang="en-US" sz="2300" b="1" dirty="0">
+                <a:solidFill>
+                  <a:srgbClr val="16A34A"/>
+                </a:solidFill>
+              </a:rPr>
+              <a:t>Ready for questions</a:t>
+            </a:r>
+            <a:endParaRPr lang="en-US" sz="2300" dirty="0"/>
+          </a:p>
+        </p:txBody>
+      </p:sp>
+      <p:sp>
+        <p:nvSpPr>
+          <p:cNvPr id="11" name="Text 9"/>
+          <p:cNvSpPr/>
+          <p:nvPr/>
+        </p:nvSpPr>
+        <p:spPr>
+          <a:xfrm>
+            <a:off x="685800" y="5897880"/>
+            <a:ext cx="8046720" cy="237744"/>
+          </a:xfrm>
+          <a:prstGeom prst="rect">
+            <a:avLst/>
+          </a:prstGeom>
+          <a:noFill/>
+          <a:ln/>
+        </p:spPr>
+        <p:txBody>
+          <a:bodyPr wrap="square" lIns="0" tIns="0" rIns="0" bIns="0" rtlCol="0" anchor="ctr"/>
+          <a:lstStyle/>
+          <a:p>
+            <a:pPr marL="0" indent="0">
+              <a:buNone/>
+            </a:pPr>
+            <a:r>
+              <a:rPr lang="en-US" sz="1300" dirty="0">
+                <a:solidFill>
+                  <a:srgbClr val="6B7280"/>
+                </a:solidFill>
+              </a:rPr>
+              <a:t>Public repo + final main + v1.0.0 release + Inspector evidence</a:t>
+            </a:r>
+            <a:endParaRPr lang="en-US" sz="1300" dirty="0"/>
+          </a:p>
+        </p:txBody>
+      </p:sp>
+      <p:sp>
+        <p:nvSpPr>
+          <p:cNvPr id="12" name="Text 10"/>
+          <p:cNvSpPr/>
+          <p:nvPr/>
+        </p:nvSpPr>
+        <p:spPr>
+          <a:xfrm>
+            <a:off x="502920" y="6455664"/>
+            <a:ext cx="2743200" cy="182880"/>
+          </a:xfrm>
+          <a:prstGeom prst="rect">
+            <a:avLst/>
+          </a:prstGeom>
+          <a:noFill/>
+          <a:ln/>
+        </p:spPr>
+        <p:txBody>
+          <a:bodyPr wrap="square" rtlCol="0" anchor="ctr"/>
+          <a:lstStyle/>
+          <a:p>
+            <a:pPr marL="0" indent="0">
+              <a:buNone/>
+            </a:pPr>
+            <a:r>
+              <a:rPr lang="en-US" sz="900" dirty="0">
+                <a:solidFill>
+                  <a:srgbClr val="6B7280"/>
+                </a:solidFill>
+              </a:rPr>
+              <a:t>Task 6.3 Demo | 5/5</a:t>
             </a:r>
             <a:endParaRPr lang="en-US" sz="900" dirty="0"/>
           </a:p>
@@ -3017,7 +4418,7 @@
   <a:extraClrSchemeLst/>
   <a:extLst>
     <a:ext uri="{05A4C25C-085E-4340-85A3-A5531E510DB2}">
-      <thm15:themeFamily xmlns:thm15="http://schemas.microsoft.com/office/thememl/2012/main" xmlns="" name="Office Theme" id="{62F939B6-93AF-4DB8-9C6B-D6C7DFDC589F}" vid="{4A3C46E8-61CC-4603-A589-7422A47A8E4A}"/>
+      <thm15:themeFamily xmlns:thm15="http://schemas.microsoft.com/office/thememl/2012/main" name="Office Theme" id="{62F939B6-93AF-4DB8-9C6B-D6C7DFDC589F}" vid="{4A3C46E8-61CC-4603-A589-7422A47A8E4A}"/>
     </a:ext>
   </a:extLst>
 </a:theme>
@@ -3034,44 +4435,44 @@
         <a:sysClr val="window" lastClr="FFFFFF"/>
       </a:lt1>
       <a:dk2>
-        <a:srgbClr val="1F497D"/>
+        <a:srgbClr val="44546A"/>
       </a:dk2>
       <a:lt2>
-        <a:srgbClr val="EEECE1"/>
+        <a:srgbClr val="E7E6E6"/>
       </a:lt2>
       <a:accent1>
-        <a:srgbClr val="4F81BD"/>
+        <a:srgbClr val="5B9BD5"/>
       </a:accent1>
       <a:accent2>
-        <a:srgbClr val="C0504D"/>
+        <a:srgbClr val="ED7D31"/>
       </a:accent2>
       <a:accent3>
-        <a:srgbClr val="9BBB59"/>
+        <a:srgbClr val="A5A5A5"/>
       </a:accent3>
       <a:accent4>
-        <a:srgbClr val="8064A2"/>
+        <a:srgbClr val="FFC000"/>
       </a:accent4>
       <a:accent5>
-        <a:srgbClr val="4BACC6"/>
+        <a:srgbClr val="4472C4"/>
       </a:accent5>
       <a:accent6>
-        <a:srgbClr val="F79646"/>
+        <a:srgbClr val="70AD47"/>
       </a:accent6>
       <a:hlink>
-        <a:srgbClr val="0000FF"/>
+        <a:srgbClr val="0563C1"/>
       </a:hlink>
       <a:folHlink>
-        <a:srgbClr val="800080"/>
+        <a:srgbClr val="954F72"/>
       </a:folHlink>
     </a:clrScheme>
     <a:fontScheme name="Office">
       <a:majorFont>
-        <a:latin typeface="Calibri"/>
+        <a:latin typeface="Calibri Light" panose="020F0302020204030204"/>
         <a:ea typeface=""/>
         <a:cs typeface=""/>
-        <a:font script="Jpan" typeface="ＭＳ Ｐゴシック"/>
+        <a:font script="Jpan" typeface="游ゴシック Light"/>
         <a:font script="Hang" typeface="맑은 고딕"/>
-        <a:font script="Hans" typeface="宋体"/>
+        <a:font script="Hans" typeface="等线 Light"/>
         <a:font script="Hant" typeface="新細明體"/>
         <a:font script="Arab" typeface="Times New Roman"/>
         <a:font script="Hebr" typeface="Times New Roman"/>
@@ -3101,12 +4502,12 @@
         <a:font script="Geor" typeface="Sylfaen"/>
       </a:majorFont>
       <a:minorFont>
-        <a:latin typeface="Calibri"/>
+        <a:latin typeface="Calibri" panose="020F0502020204030204"/>
         <a:ea typeface=""/>
         <a:cs typeface=""/>
-        <a:font script="Jpan" typeface="ＭＳ Ｐゴシック"/>
+        <a:font script="Jpan" typeface="游ゴシック"/>
         <a:font script="Hang" typeface="맑은 고딕"/>
-        <a:font script="Hans" typeface="宋体"/>
+        <a:font script="Hans" typeface="等线"/>
         <a:font script="Hant" typeface="新細明體"/>
         <a:font script="Arab" typeface="Arial"/>
         <a:font script="Hebr" typeface="Arial"/>
@@ -3145,165 +4546,141 @@
           <a:gsLst>
             <a:gs pos="0">
               <a:schemeClr val="phClr">
-                <a:tint val="50000"/>
-                <a:satMod val="300000"/>
+                <a:lumMod val="110000"/>
+                <a:satMod val="105000"/>
+                <a:tint val="67000"/>
               </a:schemeClr>
             </a:gs>
-            <a:gs pos="35000">
+            <a:gs pos="50000">
               <a:schemeClr val="phClr">
-                <a:tint val="37000"/>
-                <a:satMod val="300000"/>
+                <a:lumMod val="105000"/>
+                <a:satMod val="103000"/>
+                <a:tint val="73000"/>
               </a:schemeClr>
             </a:gs>
             <a:gs pos="100000">
               <a:schemeClr val="phClr">
-                <a:tint val="15000"/>
-                <a:satMod val="350000"/>
+                <a:lumMod val="105000"/>
+                <a:satMod val="109000"/>
+                <a:tint val="81000"/>
               </a:schemeClr>
             </a:gs>
           </a:gsLst>
-          <a:lin ang="16200000" scaled="1"/>
+          <a:lin ang="5400000" scaled="0"/>
         </a:gradFill>
         <a:gradFill rotWithShape="1">
           <a:gsLst>
             <a:gs pos="0">
               <a:schemeClr val="phClr">
-                <a:shade val="51000"/>
-                <a:satMod val="130000"/>
+                <a:satMod val="103000"/>
+                <a:lumMod val="102000"/>
+                <a:tint val="94000"/>
               </a:schemeClr>
             </a:gs>
-            <a:gs pos="80000">
+            <a:gs pos="50000">
               <a:schemeClr val="phClr">
-                <a:shade val="93000"/>
-                <a:satMod val="130000"/>
+                <a:satMod val="110000"/>
+                <a:lumMod val="100000"/>
+                <a:shade val="100000"/>
               </a:schemeClr>
             </a:gs>
             <a:gs pos="100000">
               <a:schemeClr val="phClr">
-                <a:shade val="94000"/>
-                <a:satMod val="135000"/>
+                <a:lumMod val="99000"/>
+                <a:satMod val="120000"/>
+                <a:shade val="78000"/>
               </a:schemeClr>
             </a:gs>
           </a:gsLst>
-          <a:lin ang="16200000" scaled="0"/>
+          <a:lin ang="5400000" scaled="0"/>
         </a:gradFill>
       </a:fillStyleLst>
       <a:lnStyleLst>
-        <a:ln w="9525" cap="flat" cmpd="sng" algn="ctr">
-          <a:solidFill>
-            <a:schemeClr val="phClr">
-              <a:shade val="95000"/>
-              <a:satMod val="105000"/>
-            </a:schemeClr>
-          </a:solidFill>
-          <a:prstDash val="solid"/>
-        </a:ln>
-        <a:ln w="25400" cap="flat" cmpd="sng" algn="ctr">
+        <a:ln w="6350" cap="flat" cmpd="sng" algn="ctr">
           <a:solidFill>
             <a:schemeClr val="phClr"/>
           </a:solidFill>
           <a:prstDash val="solid"/>
+          <a:miter lim="800000"/>
         </a:ln>
-        <a:ln w="38100" cap="flat" cmpd="sng" algn="ctr">
+        <a:ln w="12700" cap="flat" cmpd="sng" algn="ctr">
           <a:solidFill>
             <a:schemeClr val="phClr"/>
           </a:solidFill>
           <a:prstDash val="solid"/>
+          <a:miter lim="800000"/>
+        </a:ln>
+        <a:ln w="19050" cap="flat" cmpd="sng" algn="ctr">
+          <a:solidFill>
+            <a:schemeClr val="phClr"/>
+          </a:solidFill>
+          <a:prstDash val="solid"/>
+          <a:miter lim="800000"/>
         </a:ln>
       </a:lnStyleLst>
       <a:effectStyleLst>
         <a:effectStyle>
+          <a:effectLst/>
+        </a:effectStyle>
+        <a:effectStyle>
+          <a:effectLst/>
+        </a:effectStyle>
+        <a:effectStyle>
           <a:effectLst>
-            <a:outerShdw blurRad="40000" dist="20000" dir="5400000" rotWithShape="0">
+            <a:outerShdw blurRad="57150" dist="19050" dir="5400000" algn="ctr" rotWithShape="0">
               <a:srgbClr val="000000">
-                <a:alpha val="38000"/>
+                <a:alpha val="63000"/>
               </a:srgbClr>
             </a:outerShdw>
           </a:effectLst>
-        </a:effectStyle>
-        <a:effectStyle>
-          <a:effectLst>
-            <a:outerShdw blurRad="40000" dist="23000" dir="5400000" rotWithShape="0">
-              <a:srgbClr val="000000">
-                <a:alpha val="35000"/>
-              </a:srgbClr>
-            </a:outerShdw>
-          </a:effectLst>
-        </a:effectStyle>
-        <a:effectStyle>
-          <a:effectLst>
-            <a:outerShdw blurRad="40000" dist="23000" dir="5400000" rotWithShape="0">
-              <a:srgbClr val="000000">
-                <a:alpha val="35000"/>
-              </a:srgbClr>
-            </a:outerShdw>
-          </a:effectLst>
-          <a:scene3d>
-            <a:camera prst="orthographicFront">
-              <a:rot lat="0" lon="0" rev="0"/>
-            </a:camera>
-            <a:lightRig rig="threePt" dir="t">
-              <a:rot lat="0" lon="0" rev="1200000"/>
-            </a:lightRig>
-          </a:scene3d>
-          <a:sp3d>
-            <a:bevelT w="63500" h="25400"/>
-          </a:sp3d>
         </a:effectStyle>
       </a:effectStyleLst>
       <a:bgFillStyleLst>
         <a:solidFill>
           <a:schemeClr val="phClr"/>
         </a:solidFill>
+        <a:solidFill>
+          <a:schemeClr val="phClr">
+            <a:tint val="95000"/>
+            <a:satMod val="170000"/>
+          </a:schemeClr>
+        </a:solidFill>
         <a:gradFill rotWithShape="1">
           <a:gsLst>
             <a:gs pos="0">
               <a:schemeClr val="phClr">
-                <a:tint val="40000"/>
-                <a:satMod val="350000"/>
+                <a:tint val="93000"/>
+                <a:satMod val="150000"/>
+                <a:shade val="98000"/>
+                <a:lumMod val="102000"/>
               </a:schemeClr>
             </a:gs>
-            <a:gs pos="40000">
+            <a:gs pos="50000">
               <a:schemeClr val="phClr">
-                <a:tint val="45000"/>
-                <a:shade val="99000"/>
-                <a:satMod val="350000"/>
+                <a:tint val="98000"/>
+                <a:satMod val="130000"/>
+                <a:shade val="90000"/>
+                <a:lumMod val="103000"/>
               </a:schemeClr>
             </a:gs>
             <a:gs pos="100000">
               <a:schemeClr val="phClr">
-                <a:shade val="20000"/>
-                <a:satMod val="255000"/>
+                <a:shade val="63000"/>
+                <a:satMod val="120000"/>
               </a:schemeClr>
             </a:gs>
           </a:gsLst>
-          <a:path path="circle">
-            <a:fillToRect l="50000" t="-80000" r="50000" b="180000"/>
-          </a:path>
-        </a:gradFill>
-        <a:gradFill rotWithShape="1">
-          <a:gsLst>
-            <a:gs pos="0">
-              <a:schemeClr val="phClr">
-                <a:tint val="80000"/>
-                <a:satMod val="300000"/>
-              </a:schemeClr>
-            </a:gs>
-            <a:gs pos="100000">
-              <a:schemeClr val="phClr">
-                <a:shade val="30000"/>
-                <a:satMod val="200000"/>
-              </a:schemeClr>
-            </a:gs>
-          </a:gsLst>
-          <a:path path="circle">
-            <a:fillToRect l="50000" t="50000" r="50000" b="50000"/>
-          </a:path>
+          <a:lin ang="5400000" scaled="0"/>
         </a:gradFill>
       </a:bgFillStyleLst>
     </a:fmtScheme>
   </a:themeElements>
   <a:objectDefaults/>
   <a:extraClrSchemeLst/>
+  <a:extLst>
+    <a:ext uri="{05A4C25C-085E-4340-85A3-A5531E510DB2}">
+      <thm15:themeFamily xmlns:thm15="http://schemas.microsoft.com/office/thememl/2012/main" name="Office Theme" id="{62F939B6-93AF-4DB8-9C6B-D6C7DFDC589F}" vid="{4A3C46E8-61CC-4603-A589-7422A47A8E4A}"/>
+    </a:ext>
+  </a:extLst>
 </a:theme>
 </file>
</xml_diff>

<commit_message>
docs(week6): complete demo flow and tool coverage (#72)
</commit_message>
<xml_diff>
--- a/docs/demo-slides.pptx
+++ b/docs/demo-slides.pptx
@@ -5,12 +5,14 @@
     <p:sldMasterId id="2147483648" r:id="rId1"/>
   </p:sldMasterIdLst>
   <p:notesMasterIdLst>
-    <p:notesMasterId r:id="rId5"/>
+    <p:notesMasterId r:id="rId7"/>
   </p:notesMasterIdLst>
   <p:sldIdLst>
     <p:sldId id="256" r:id="rId2"/>
     <p:sldId id="257" r:id="rId3"/>
     <p:sldId id="258" r:id="rId4"/>
+    <p:sldId id="259" r:id="rId5"/>
+    <p:sldId id="260" r:id="rId6"/>
   </p:sldIdLst>
   <p:sldSz cx="12192000" cy="6858000"/>
   <p:notesSz cx="6858000" cy="12192000"/>
@@ -106,6 +108,11 @@
       </a:defRPr>
     </a:lvl9pPr>
   </p:defaultTextStyle>
+  <p:extLst>
+    <p:ext uri="{EFAFB233-063F-42B5-8137-9DF3F51BA10A}">
+      <p15:sldGuideLst xmlns:p15="http://schemas.microsoft.com/office/powerpoint/2012/main"/>
+    </p:ext>
+  </p:extLst>
 </p:presentation>
 </file>
 
@@ -131,241 +138,16 @@
           <a:chExt cx="0" cy="0"/>
         </a:xfrm>
       </p:grpSpPr>
-      <p:sp>
-        <p:nvSpPr>
-          <p:cNvPr id="2" name="Header Placeholder 1"/>
-          <p:cNvSpPr>
-            <a:spLocks noGrp="1"/>
-          </p:cNvSpPr>
-          <p:nvPr>
-            <p:ph type="hdr" sz="quarter"/>
-          </p:nvPr>
-        </p:nvSpPr>
-        <p:spPr>
-          <a:xfrm>
-            <a:off x="3886200" y="0"/>
-            <a:ext cx="2971800" cy="609600"/>
-          </a:xfrm>
-          <a:prstGeom prst="rect">
-            <a:avLst/>
-          </a:prstGeom>
-        </p:spPr>
-        <p:txBody>
-          <a:bodyPr vert="horz" lIns="91440" tIns="45720" rIns="91440" bIns="45720" rtlCol="1"/>
-          <a:lstStyle>
-            <a:lvl1pPr algn="r">
-              <a:defRPr sz="1200"/>
-            </a:lvl1pPr>
-          </a:lstStyle>
-          <a:p>
-            <a:endParaRPr lang="ar-SA"/>
-          </a:p>
-        </p:txBody>
-      </p:sp>
-      <p:sp>
-        <p:nvSpPr>
-          <p:cNvPr id="3" name="Date Placeholder 2"/>
-          <p:cNvSpPr>
-            <a:spLocks noGrp="1"/>
-          </p:cNvSpPr>
-          <p:nvPr>
-            <p:ph type="dt" idx="1"/>
-          </p:nvPr>
-        </p:nvSpPr>
-        <p:spPr>
-          <a:xfrm>
-            <a:off x="1588" y="0"/>
-            <a:ext cx="2971800" cy="609600"/>
-          </a:xfrm>
-          <a:prstGeom prst="rect">
-            <a:avLst/>
-          </a:prstGeom>
-        </p:spPr>
-        <p:txBody>
-          <a:bodyPr vert="horz" lIns="91440" tIns="45720" rIns="91440" bIns="45720" rtlCol="1"/>
-          <a:lstStyle>
-            <a:lvl1pPr algn="l">
-              <a:defRPr sz="1200"/>
-            </a:lvl1pPr>
-          </a:lstStyle>
-          <a:p>
-            <a:fld id="{348DEE78-52B5-4ED4-9C40-D54C7EC1C00B}" type="datetimeFigureOut">
-              <a:rPr lang="ar-SA" smtClean="0"/>
-              <a:t>10/03/1448</a:t>
-            </a:fld>
-            <a:endParaRPr lang="ar-SA"/>
-          </a:p>
-        </p:txBody>
-      </p:sp>
-      <p:sp>
-        <p:nvSpPr>
-          <p:cNvPr id="4" name="Slide Image Placeholder 3"/>
-          <p:cNvSpPr>
-            <a:spLocks noGrp="1" noRot="1" noChangeAspect="1"/>
-          </p:cNvSpPr>
-          <p:nvPr>
-            <p:ph type="sldImg" idx="2"/>
-          </p:nvPr>
-        </p:nvSpPr>
-        <p:spPr>
-          <a:xfrm>
-            <a:off x="-635000" y="914400"/>
-            <a:ext cx="8128000" cy="4572000"/>
-          </a:xfrm>
-          <a:prstGeom prst="rect">
-            <a:avLst/>
-          </a:prstGeom>
-          <a:noFill/>
-          <a:ln w="12700">
-            <a:solidFill>
-              <a:prstClr val="black"/>
-            </a:solidFill>
-          </a:ln>
-        </p:spPr>
-        <p:txBody>
-          <a:bodyPr vert="horz" lIns="91440" tIns="45720" rIns="91440" bIns="45720" rtlCol="1" anchor="ctr"/>
-          <a:lstStyle/>
-          <a:p>
-            <a:endParaRPr lang="ar-SA"/>
-          </a:p>
-        </p:txBody>
-      </p:sp>
-      <p:sp>
-        <p:nvSpPr>
-          <p:cNvPr id="5" name="Notes Placeholder 4"/>
-          <p:cNvSpPr>
-            <a:spLocks noGrp="1"/>
-          </p:cNvSpPr>
-          <p:nvPr>
-            <p:ph type="body" sz="quarter" idx="3"/>
-          </p:nvPr>
-        </p:nvSpPr>
-        <p:spPr>
-          <a:xfrm>
-            <a:off x="685800" y="5791200"/>
-            <a:ext cx="5486400" cy="5486400"/>
-          </a:xfrm>
-          <a:prstGeom prst="rect">
-            <a:avLst/>
-          </a:prstGeom>
-        </p:spPr>
-        <p:txBody>
-          <a:bodyPr vert="horz" lIns="91440" tIns="45720" rIns="91440" bIns="45720" rtlCol="1"/>
-          <a:lstStyle/>
-          <a:p>
-            <a:pPr lvl="0"/>
-            <a:r>
-              <a:rPr lang="en-US" smtClean="0"/>
-              <a:t>Click to edit Master text styles</a:t>
-            </a:r>
-          </a:p>
-          <a:p>
-            <a:pPr lvl="1"/>
-            <a:r>
-              <a:rPr lang="en-US" smtClean="0"/>
-              <a:t>Second level</a:t>
-            </a:r>
-          </a:p>
-          <a:p>
-            <a:pPr lvl="2"/>
-            <a:r>
-              <a:rPr lang="en-US" smtClean="0"/>
-              <a:t>Third level</a:t>
-            </a:r>
-          </a:p>
-          <a:p>
-            <a:pPr lvl="3"/>
-            <a:r>
-              <a:rPr lang="en-US" smtClean="0"/>
-              <a:t>Fourth level</a:t>
-            </a:r>
-          </a:p>
-          <a:p>
-            <a:pPr lvl="4"/>
-            <a:r>
-              <a:rPr lang="en-US" smtClean="0"/>
-              <a:t>Fifth level</a:t>
-            </a:r>
-            <a:endParaRPr lang="ar-SA"/>
-          </a:p>
-        </p:txBody>
-      </p:sp>
-      <p:sp>
-        <p:nvSpPr>
-          <p:cNvPr id="6" name="Footer Placeholder 5"/>
-          <p:cNvSpPr>
-            <a:spLocks noGrp="1"/>
-          </p:cNvSpPr>
-          <p:nvPr>
-            <p:ph type="ftr" sz="quarter" idx="4"/>
-          </p:nvPr>
-        </p:nvSpPr>
-        <p:spPr>
-          <a:xfrm>
-            <a:off x="3886200" y="11580813"/>
-            <a:ext cx="2971800" cy="609600"/>
-          </a:xfrm>
-          <a:prstGeom prst="rect">
-            <a:avLst/>
-          </a:prstGeom>
-        </p:spPr>
-        <p:txBody>
-          <a:bodyPr vert="horz" lIns="91440" tIns="45720" rIns="91440" bIns="45720" rtlCol="1" anchor="b"/>
-          <a:lstStyle>
-            <a:lvl1pPr algn="r">
-              <a:defRPr sz="1200"/>
-            </a:lvl1pPr>
-          </a:lstStyle>
-          <a:p>
-            <a:endParaRPr lang="ar-SA"/>
-          </a:p>
-        </p:txBody>
-      </p:sp>
-      <p:sp>
-        <p:nvSpPr>
-          <p:cNvPr id="7" name="Slide Number Placeholder 6"/>
-          <p:cNvSpPr>
-            <a:spLocks noGrp="1"/>
-          </p:cNvSpPr>
-          <p:nvPr>
-            <p:ph type="sldNum" sz="quarter" idx="5"/>
-          </p:nvPr>
-        </p:nvSpPr>
-        <p:spPr>
-          <a:xfrm>
-            <a:off x="1588" y="11580813"/>
-            <a:ext cx="2971800" cy="609600"/>
-          </a:xfrm>
-          <a:prstGeom prst="rect">
-            <a:avLst/>
-          </a:prstGeom>
-        </p:spPr>
-        <p:txBody>
-          <a:bodyPr vert="horz" lIns="91440" tIns="45720" rIns="91440" bIns="45720" rtlCol="1" anchor="b"/>
-          <a:lstStyle>
-            <a:lvl1pPr algn="l">
-              <a:defRPr sz="1200"/>
-            </a:lvl1pPr>
-          </a:lstStyle>
-          <a:p>
-            <a:fld id="{00EEEE06-C8FB-487A-B8B6-8B759C4104CF}" type="slidenum">
-              <a:rPr lang="ar-SA" smtClean="0"/>
-              <a:t>‹#›</a:t>
-            </a:fld>
-            <a:endParaRPr lang="ar-SA"/>
-          </a:p>
-        </p:txBody>
-      </p:sp>
     </p:spTree>
     <p:extLst>
       <p:ext uri="{BB962C8B-B14F-4D97-AF65-F5344CB8AC3E}">
-        <p14:creationId xmlns:p14="http://schemas.microsoft.com/office/powerpoint/2010/main" val="677259299"/>
+        <p14:creationId xmlns:p14="http://schemas.microsoft.com/office/powerpoint/2010/main" val="279848868"/>
       </p:ext>
     </p:extLst>
   </p:cSld>
   <p:clrMap bg1="lt1" tx1="dk1" bg2="lt2" tx2="dk2" accent1="accent1" accent2="accent2" accent3="accent3" accent4="accent4" accent5="accent5" accent6="accent6" hlink="hlink" folHlink="folHlink"/>
   <p:notesStyle>
-    <a:lvl1pPr marL="0" algn="r" defTabSz="914400" rtl="1" eaLnBrk="1" latinLnBrk="0" hangingPunct="1">
+    <a:lvl1pPr marL="0" algn="l" defTabSz="914400" rtl="0" eaLnBrk="1" latinLnBrk="0" hangingPunct="1">
       <a:defRPr sz="1200" kern="1200">
         <a:solidFill>
           <a:schemeClr val="tx1"/>
@@ -375,7 +157,7 @@
         <a:cs typeface="+mn-cs"/>
       </a:defRPr>
     </a:lvl1pPr>
-    <a:lvl2pPr marL="457200" algn="r" defTabSz="914400" rtl="1" eaLnBrk="1" latinLnBrk="0" hangingPunct="1">
+    <a:lvl2pPr marL="457200" algn="l" defTabSz="914400" rtl="0" eaLnBrk="1" latinLnBrk="0" hangingPunct="1">
       <a:defRPr sz="1200" kern="1200">
         <a:solidFill>
           <a:schemeClr val="tx1"/>
@@ -385,7 +167,7 @@
         <a:cs typeface="+mn-cs"/>
       </a:defRPr>
     </a:lvl2pPr>
-    <a:lvl3pPr marL="914400" algn="r" defTabSz="914400" rtl="1" eaLnBrk="1" latinLnBrk="0" hangingPunct="1">
+    <a:lvl3pPr marL="914400" algn="l" defTabSz="914400" rtl="0" eaLnBrk="1" latinLnBrk="0" hangingPunct="1">
       <a:defRPr sz="1200" kern="1200">
         <a:solidFill>
           <a:schemeClr val="tx1"/>
@@ -395,7 +177,7 @@
         <a:cs typeface="+mn-cs"/>
       </a:defRPr>
     </a:lvl3pPr>
-    <a:lvl4pPr marL="1371600" algn="r" defTabSz="914400" rtl="1" eaLnBrk="1" latinLnBrk="0" hangingPunct="1">
+    <a:lvl4pPr marL="1371600" algn="l" defTabSz="914400" rtl="0" eaLnBrk="1" latinLnBrk="0" hangingPunct="1">
       <a:defRPr sz="1200" kern="1200">
         <a:solidFill>
           <a:schemeClr val="tx1"/>
@@ -405,7 +187,7 @@
         <a:cs typeface="+mn-cs"/>
       </a:defRPr>
     </a:lvl4pPr>
-    <a:lvl5pPr marL="1828800" algn="r" defTabSz="914400" rtl="1" eaLnBrk="1" latinLnBrk="0" hangingPunct="1">
+    <a:lvl5pPr marL="1828800" algn="l" defTabSz="914400" rtl="0" eaLnBrk="1" latinLnBrk="0" hangingPunct="1">
       <a:defRPr sz="1200" kern="1200">
         <a:solidFill>
           <a:schemeClr val="tx1"/>
@@ -415,7 +197,7 @@
         <a:cs typeface="+mn-cs"/>
       </a:defRPr>
     </a:lvl5pPr>
-    <a:lvl6pPr marL="2286000" algn="r" defTabSz="914400" rtl="1" eaLnBrk="1" latinLnBrk="0" hangingPunct="1">
+    <a:lvl6pPr marL="2286000" algn="l" defTabSz="914400" rtl="0" eaLnBrk="1" latinLnBrk="0" hangingPunct="1">
       <a:defRPr sz="1200" kern="1200">
         <a:solidFill>
           <a:schemeClr val="tx1"/>
@@ -425,7 +207,7 @@
         <a:cs typeface="+mn-cs"/>
       </a:defRPr>
     </a:lvl6pPr>
-    <a:lvl7pPr marL="2743200" algn="r" defTabSz="914400" rtl="1" eaLnBrk="1" latinLnBrk="0" hangingPunct="1">
+    <a:lvl7pPr marL="2743200" algn="l" defTabSz="914400" rtl="0" eaLnBrk="1" latinLnBrk="0" hangingPunct="1">
       <a:defRPr sz="1200" kern="1200">
         <a:solidFill>
           <a:schemeClr val="tx1"/>
@@ -435,7 +217,7 @@
         <a:cs typeface="+mn-cs"/>
       </a:defRPr>
     </a:lvl7pPr>
-    <a:lvl8pPr marL="3200400" algn="r" defTabSz="914400" rtl="1" eaLnBrk="1" latinLnBrk="0" hangingPunct="1">
+    <a:lvl8pPr marL="3200400" algn="l" defTabSz="914400" rtl="0" eaLnBrk="1" latinLnBrk="0" hangingPunct="1">
       <a:defRPr sz="1200" kern="1200">
         <a:solidFill>
           <a:schemeClr val="tx1"/>
@@ -445,7 +227,7 @@
         <a:cs typeface="+mn-cs"/>
       </a:defRPr>
     </a:lvl8pPr>
-    <a:lvl9pPr marL="3657600" algn="r" defTabSz="914400" rtl="1" eaLnBrk="1" latinLnBrk="0" hangingPunct="1">
+    <a:lvl9pPr marL="3657600" algn="l" defTabSz="914400" rtl="0" eaLnBrk="1" latinLnBrk="0" hangingPunct="1">
       <a:defRPr sz="1200" kern="1200">
         <a:solidFill>
           <a:schemeClr val="tx1"/>
@@ -693,6 +475,174 @@
             <a:fld id="{F7021451-1387-4CA6-816F-3879F97B5CBC}" type="slidenum">
               <a:rPr lang="en-US"/>
               <a:t>3</a:t>
+            </a:fld>
+            <a:endParaRPr lang="en-US"/>
+          </a:p>
+        </p:txBody>
+      </p:sp>
+    </p:spTree>
+    <p:extLst>
+      <p:ext uri="{BB962C8B-B14F-4D97-AF65-F5344CB8AC3E}">
+        <p14:creationId xmlns:p14="http://schemas.microsoft.com/office/powerpoint/2010/main" val="1024086991"/>
+      </p:ext>
+    </p:extLst>
+  </p:cSld>
+  <p:clrMapOvr>
+    <a:masterClrMapping/>
+  </p:clrMapOvr>
+</p:notes>
+</file>
+
+<file path=ppt/notesSlides/notesSlide4.xml><?xml version="1.0" encoding="utf-8"?>
+<p:notes xmlns:a="http://schemas.openxmlformats.org/drawingml/2006/main" xmlns:r="http://schemas.openxmlformats.org/officeDocument/2006/relationships" xmlns:p="http://schemas.openxmlformats.org/presentationml/2006/main">
+  <p:cSld>
+    <p:spTree>
+      <p:nvGrpSpPr>
+        <p:cNvPr id="1" name=""/>
+        <p:cNvGrpSpPr/>
+        <p:nvPr/>
+      </p:nvGrpSpPr>
+      <p:grpSpPr>
+        <a:xfrm>
+          <a:off x="0" y="0"/>
+          <a:ext cx="0" cy="0"/>
+          <a:chOff x="0" y="0"/>
+          <a:chExt cx="0" cy="0"/>
+        </a:xfrm>
+      </p:grpSpPr>
+      <p:sp>
+        <p:nvSpPr>
+          <p:cNvPr id="2" name="Slide Image Placeholder 1"/>
+          <p:cNvSpPr>
+            <a:spLocks noGrp="1" noRot="1" noChangeAspect="1"/>
+          </p:cNvSpPr>
+          <p:nvPr>
+            <p:ph type="sldImg"/>
+          </p:nvPr>
+        </p:nvSpPr>
+        <p:spPr/>
+      </p:sp>
+      <p:sp>
+        <p:nvSpPr>
+          <p:cNvPr id="3" name="Notes Placeholder 2"/>
+          <p:cNvSpPr>
+            <a:spLocks noGrp="1"/>
+          </p:cNvSpPr>
+          <p:nvPr>
+            <p:ph type="body" idx="1"/>
+          </p:nvPr>
+        </p:nvSpPr>
+        <p:spPr/>
+        <p:txBody>
+          <a:bodyPr/>
+          <a:lstStyle/>
+          <a:p>
+            <a:endParaRPr lang="en-US" dirty="0"/>
+          </a:p>
+        </p:txBody>
+      </p:sp>
+      <p:sp>
+        <p:nvSpPr>
+          <p:cNvPr id="4" name="Slide Number Placeholder 3"/>
+          <p:cNvSpPr>
+            <a:spLocks noGrp="1"/>
+          </p:cNvSpPr>
+          <p:nvPr>
+            <p:ph type="sldNum" sz="quarter" idx="10"/>
+          </p:nvPr>
+        </p:nvSpPr>
+        <p:spPr/>
+        <p:txBody>
+          <a:bodyPr/>
+          <a:lstStyle/>
+          <a:p>
+            <a:fld id="{F7021451-1387-4CA6-816F-3879F97B5CBC}" type="slidenum">
+              <a:rPr lang="en-US"/>
+              <a:t>4</a:t>
+            </a:fld>
+            <a:endParaRPr lang="en-US"/>
+          </a:p>
+        </p:txBody>
+      </p:sp>
+    </p:spTree>
+    <p:extLst>
+      <p:ext uri="{BB962C8B-B14F-4D97-AF65-F5344CB8AC3E}">
+        <p14:creationId xmlns:p14="http://schemas.microsoft.com/office/powerpoint/2010/main" val="1024086991"/>
+      </p:ext>
+    </p:extLst>
+  </p:cSld>
+  <p:clrMapOvr>
+    <a:masterClrMapping/>
+  </p:clrMapOvr>
+</p:notes>
+</file>
+
+<file path=ppt/notesSlides/notesSlide5.xml><?xml version="1.0" encoding="utf-8"?>
+<p:notes xmlns:a="http://schemas.openxmlformats.org/drawingml/2006/main" xmlns:r="http://schemas.openxmlformats.org/officeDocument/2006/relationships" xmlns:p="http://schemas.openxmlformats.org/presentationml/2006/main">
+  <p:cSld>
+    <p:spTree>
+      <p:nvGrpSpPr>
+        <p:cNvPr id="1" name=""/>
+        <p:cNvGrpSpPr/>
+        <p:nvPr/>
+      </p:nvGrpSpPr>
+      <p:grpSpPr>
+        <a:xfrm>
+          <a:off x="0" y="0"/>
+          <a:ext cx="0" cy="0"/>
+          <a:chOff x="0" y="0"/>
+          <a:chExt cx="0" cy="0"/>
+        </a:xfrm>
+      </p:grpSpPr>
+      <p:sp>
+        <p:nvSpPr>
+          <p:cNvPr id="2" name="Slide Image Placeholder 1"/>
+          <p:cNvSpPr>
+            <a:spLocks noGrp="1" noRot="1" noChangeAspect="1"/>
+          </p:cNvSpPr>
+          <p:nvPr>
+            <p:ph type="sldImg"/>
+          </p:nvPr>
+        </p:nvSpPr>
+        <p:spPr/>
+      </p:sp>
+      <p:sp>
+        <p:nvSpPr>
+          <p:cNvPr id="3" name="Notes Placeholder 2"/>
+          <p:cNvSpPr>
+            <a:spLocks noGrp="1"/>
+          </p:cNvSpPr>
+          <p:nvPr>
+            <p:ph type="body" idx="1"/>
+          </p:nvPr>
+        </p:nvSpPr>
+        <p:spPr/>
+        <p:txBody>
+          <a:bodyPr/>
+          <a:lstStyle/>
+          <a:p>
+            <a:endParaRPr lang="en-US" dirty="0"/>
+          </a:p>
+        </p:txBody>
+      </p:sp>
+      <p:sp>
+        <p:nvSpPr>
+          <p:cNvPr id="4" name="Slide Number Placeholder 3"/>
+          <p:cNvSpPr>
+            <a:spLocks noGrp="1"/>
+          </p:cNvSpPr>
+          <p:nvPr>
+            <p:ph type="sldNum" sz="quarter" idx="10"/>
+          </p:nvPr>
+        </p:nvSpPr>
+        <p:spPr/>
+        <p:txBody>
+          <a:bodyPr/>
+          <a:lstStyle/>
+          <a:p>
+            <a:fld id="{F7021451-1387-4CA6-816F-3879F97B5CBC}" type="slidenum">
+              <a:rPr lang="en-US"/>
+              <a:t>5</a:t>
             </a:fld>
             <a:endParaRPr lang="en-US"/>
           </a:p>
@@ -1544,11 +1494,8 @@
           <a:bodyPr wrap="square" lIns="0" tIns="0" rIns="0" bIns="0" rtlCol="0" anchor="ctr"/>
           <a:lstStyle/>
           <a:p>
-            <a:pPr marL="0" indent="0">
-              <a:buNone/>
-            </a:pPr>
-            <a:r>
-              <a:rPr lang="en-US" sz="1100" dirty="0" err="1" smtClean="0">
+            <a:r>
+              <a:rPr lang="en-US" sz="1100" dirty="0" err="1">
                 <a:solidFill>
                   <a:srgbClr val="6B7280"/>
                 </a:solidFill>
@@ -1556,7 +1503,7 @@
               <a:t>Saja</a:t>
             </a:r>
             <a:r>
-              <a:rPr lang="en-US" sz="1100" dirty="0" smtClean="0">
+              <a:rPr lang="en-US" sz="1100" dirty="0">
                 <a:solidFill>
                   <a:srgbClr val="6B7280"/>
                 </a:solidFill>
@@ -1564,7 +1511,7 @@
               <a:t> </a:t>
             </a:r>
             <a:r>
-              <a:rPr lang="en-US" sz="1100" dirty="0" err="1" smtClean="0">
+              <a:rPr lang="en-US" sz="1100" dirty="0" err="1">
                 <a:solidFill>
                   <a:srgbClr val="6B7280"/>
                 </a:solidFill>
@@ -1572,69 +1519,51 @@
               <a:t>Asfour</a:t>
             </a:r>
             <a:r>
-              <a:rPr lang="en-US" sz="1100" dirty="0" smtClean="0">
+              <a:rPr lang="en-US" sz="1100" dirty="0">
                 <a:solidFill>
                   <a:srgbClr val="6B7280"/>
                 </a:solidFill>
               </a:rPr>
-              <a:t>  &amp; </a:t>
-            </a:r>
-            <a:r>
-              <a:rPr lang="en-US" sz="1100" dirty="0" err="1" smtClean="0">
+              <a:t>  &amp; Yara </a:t>
+            </a:r>
+            <a:r>
+              <a:rPr lang="en-US" sz="1100" dirty="0" err="1">
                 <a:solidFill>
                   <a:srgbClr val="6B7280"/>
                 </a:solidFill>
               </a:rPr>
-              <a:t>Yara</a:t>
-            </a:r>
-            <a:r>
-              <a:rPr lang="en-US" sz="1100" dirty="0" smtClean="0">
+              <a:t>Khattab</a:t>
+            </a:r>
+            <a:r>
+              <a:rPr lang="en-US" sz="1100" dirty="0">
                 <a:solidFill>
                   <a:srgbClr val="6B7280"/>
                 </a:solidFill>
               </a:rPr>
-              <a:t> </a:t>
-            </a:r>
-            <a:r>
-              <a:rPr lang="en-US" sz="1100" dirty="0" err="1" smtClean="0">
+              <a:t> | </a:t>
+            </a:r>
+            <a:r>
+              <a:rPr lang="en-US" sz="1100" dirty="0" err="1">
                 <a:solidFill>
                   <a:srgbClr val="6B7280"/>
                 </a:solidFill>
               </a:rPr>
-              <a:t>Khattab</a:t>
-            </a:r>
-            <a:r>
-              <a:rPr lang="en-US" sz="1100" dirty="0" smtClean="0">
+              <a:t>NextFlows</a:t>
+            </a:r>
+            <a:r>
+              <a:rPr lang="en-US" sz="1100" dirty="0">
                 <a:solidFill>
                   <a:srgbClr val="6B7280"/>
                 </a:solidFill>
               </a:rPr>
-              <a:t> | </a:t>
-            </a:r>
-            <a:r>
-              <a:rPr lang="en-US" sz="1100" dirty="0" err="1" smtClean="0">
-                <a:solidFill>
-                  <a:srgbClr val="6B7280"/>
-                </a:solidFill>
-              </a:rPr>
-              <a:t>NextFlows</a:t>
-            </a:r>
-            <a:r>
-              <a:rPr lang="en-US" sz="1100" dirty="0" smtClean="0">
-                <a:solidFill>
-                  <a:srgbClr val="6B7280"/>
-                </a:solidFill>
-              </a:rPr>
-              <a:t> </a:t>
-            </a:r>
-            <a:r>
-              <a:rPr lang="en-US" sz="1100" dirty="0">
-                <a:solidFill>
-                  <a:srgbClr val="6B7280"/>
-                </a:solidFill>
-              </a:rPr>
-              <a:t>Academy</a:t>
-            </a:r>
+              <a:t> Academy</a:t>
+            </a:r>
+            <a:endParaRPr lang="en-US" sz="1100" dirty="0"/>
+          </a:p>
+          <a:p>
+            <a:pPr marL="0" indent="0">
+              <a:buNone/>
+            </a:pPr>
             <a:endParaRPr lang="en-US" sz="1100" dirty="0"/>
           </a:p>
         </p:txBody>
@@ -2715,6 +2644,1478 @@
                 </a:solidFill>
               </a:rPr>
               <a:t>Task 6.3 Demo | 3/5</a:t>
+            </a:r>
+            <a:endParaRPr lang="en-US" sz="900" dirty="0"/>
+          </a:p>
+        </p:txBody>
+      </p:sp>
+    </p:spTree>
+  </p:cSld>
+  <p:clrMapOvr>
+    <a:masterClrMapping/>
+  </p:clrMapOvr>
+</p:sld>
+</file>
+
+<file path=ppt/slides/slide4.xml><?xml version="1.0" encoding="utf-8"?>
+<p:sld xmlns:a="http://schemas.openxmlformats.org/drawingml/2006/main" xmlns:r="http://schemas.openxmlformats.org/officeDocument/2006/relationships" xmlns:p="http://schemas.openxmlformats.org/presentationml/2006/main">
+  <p:cSld name="Slide 4">
+    <p:bg>
+      <p:bgPr>
+        <a:solidFill>
+          <a:srgbClr val="FFFFFF"/>
+        </a:solidFill>
+        <a:effectLst/>
+      </p:bgPr>
+    </p:bg>
+    <p:spTree>
+      <p:nvGrpSpPr>
+        <p:cNvPr id="1" name=""/>
+        <p:cNvGrpSpPr/>
+        <p:nvPr/>
+      </p:nvGrpSpPr>
+      <p:grpSpPr>
+        <a:xfrm>
+          <a:off x="0" y="0"/>
+          <a:ext cx="0" cy="0"/>
+          <a:chOff x="0" y="0"/>
+          <a:chExt cx="0" cy="0"/>
+        </a:xfrm>
+      </p:grpSpPr>
+      <p:sp>
+        <p:nvSpPr>
+          <p:cNvPr id="2" name="Text 0"/>
+          <p:cNvSpPr/>
+          <p:nvPr/>
+        </p:nvSpPr>
+        <p:spPr>
+          <a:xfrm>
+            <a:off x="502920" y="320040"/>
+            <a:ext cx="7772400" cy="411480"/>
+          </a:xfrm>
+          <a:prstGeom prst="rect">
+            <a:avLst/>
+          </a:prstGeom>
+          <a:noFill/>
+          <a:ln/>
+        </p:spPr>
+        <p:txBody>
+          <a:bodyPr wrap="square" lIns="0" tIns="0" rIns="0" bIns="0" rtlCol="0" anchor="ctr"/>
+          <a:lstStyle/>
+          <a:p>
+            <a:pPr marL="0" indent="0">
+              <a:buNone/>
+            </a:pPr>
+            <a:r>
+              <a:rPr lang="en-US" sz="2800" b="1" dirty="0">
+                <a:solidFill>
+                  <a:srgbClr val="111827"/>
+                </a:solidFill>
+              </a:rPr>
+              <a:t>Tool coverage</a:t>
+            </a:r>
+            <a:endParaRPr lang="en-US" sz="2800" dirty="0"/>
+          </a:p>
+        </p:txBody>
+      </p:sp>
+      <p:sp>
+        <p:nvSpPr>
+          <p:cNvPr id="3" name="Text 1"/>
+          <p:cNvSpPr/>
+          <p:nvPr/>
+        </p:nvSpPr>
+        <p:spPr>
+          <a:xfrm>
+            <a:off x="502920" y="822960"/>
+            <a:ext cx="8595360" cy="274320"/>
+          </a:xfrm>
+          <a:prstGeom prst="rect">
+            <a:avLst/>
+          </a:prstGeom>
+          <a:noFill/>
+          <a:ln/>
+        </p:spPr>
+        <p:txBody>
+          <a:bodyPr wrap="square" lIns="0" tIns="0" rIns="0" bIns="0" rtlCol="0" anchor="ctr"/>
+          <a:lstStyle/>
+          <a:p>
+            <a:pPr marL="0" indent="0">
+              <a:buNone/>
+            </a:pPr>
+            <a:r>
+              <a:rPr lang="en-US" sz="1400" dirty="0">
+                <a:solidFill>
+                  <a:srgbClr val="6B7280"/>
+                </a:solidFill>
+              </a:rPr>
+              <a:t>The full server exposes five real MCP tools plus two resources.</a:t>
+            </a:r>
+            <a:endParaRPr lang="en-US" sz="1400" dirty="0"/>
+          </a:p>
+        </p:txBody>
+      </p:sp>
+      <p:sp>
+        <p:nvSpPr>
+          <p:cNvPr id="4" name="Shape 2"/>
+          <p:cNvSpPr/>
+          <p:nvPr/>
+        </p:nvSpPr>
+        <p:spPr>
+          <a:xfrm>
+            <a:off x="685800" y="1325880"/>
+            <a:ext cx="10789920" cy="4160520"/>
+          </a:xfrm>
+          <a:prstGeom prst="roundRect">
+            <a:avLst>
+              <a:gd name="adj" fmla="val 1758"/>
+            </a:avLst>
+          </a:prstGeom>
+          <a:solidFill>
+            <a:srgbClr val="FFFFFF"/>
+          </a:solidFill>
+          <a:ln w="12700">
+            <a:solidFill>
+              <a:srgbClr val="E5E7EB"/>
+            </a:solidFill>
+            <a:prstDash val="solid"/>
+          </a:ln>
+        </p:spPr>
+      </p:sp>
+      <p:sp>
+        <p:nvSpPr>
+          <p:cNvPr id="5" name="Text 3"/>
+          <p:cNvSpPr/>
+          <p:nvPr/>
+        </p:nvSpPr>
+        <p:spPr>
+          <a:xfrm>
+            <a:off x="941832" y="1545336"/>
+            <a:ext cx="2011680" cy="228600"/>
+          </a:xfrm>
+          <a:prstGeom prst="rect">
+            <a:avLst/>
+          </a:prstGeom>
+          <a:noFill/>
+          <a:ln/>
+        </p:spPr>
+        <p:txBody>
+          <a:bodyPr wrap="square" lIns="0" tIns="0" rIns="0" bIns="0" rtlCol="0" anchor="ctr"/>
+          <a:lstStyle/>
+          <a:p>
+            <a:pPr marL="0" indent="0">
+              <a:buNone/>
+            </a:pPr>
+            <a:r>
+              <a:rPr lang="en-US" sz="1300" b="1" dirty="0">
+                <a:solidFill>
+                  <a:srgbClr val="111827"/>
+                </a:solidFill>
+              </a:rPr>
+              <a:t>Tool</a:t>
+            </a:r>
+            <a:endParaRPr lang="en-US" sz="1300" dirty="0"/>
+          </a:p>
+        </p:txBody>
+      </p:sp>
+      <p:sp>
+        <p:nvSpPr>
+          <p:cNvPr id="6" name="Text 4"/>
+          <p:cNvSpPr/>
+          <p:nvPr/>
+        </p:nvSpPr>
+        <p:spPr>
+          <a:xfrm>
+            <a:off x="3429000" y="1545336"/>
+            <a:ext cx="3657600" cy="228600"/>
+          </a:xfrm>
+          <a:prstGeom prst="rect">
+            <a:avLst/>
+          </a:prstGeom>
+          <a:noFill/>
+          <a:ln/>
+        </p:spPr>
+        <p:txBody>
+          <a:bodyPr wrap="square" lIns="0" tIns="0" rIns="0" bIns="0" rtlCol="0" anchor="ctr"/>
+          <a:lstStyle/>
+          <a:p>
+            <a:pPr marL="0" indent="0">
+              <a:buNone/>
+            </a:pPr>
+            <a:r>
+              <a:rPr lang="en-US" sz="1300" b="1" dirty="0">
+                <a:solidFill>
+                  <a:srgbClr val="111827"/>
+                </a:solidFill>
+              </a:rPr>
+              <a:t>Purpose</a:t>
+            </a:r>
+            <a:endParaRPr lang="en-US" sz="1300" dirty="0"/>
+          </a:p>
+        </p:txBody>
+      </p:sp>
+      <p:sp>
+        <p:nvSpPr>
+          <p:cNvPr id="7" name="Text 5"/>
+          <p:cNvSpPr/>
+          <p:nvPr/>
+        </p:nvSpPr>
+        <p:spPr>
+          <a:xfrm>
+            <a:off x="8001000" y="1545336"/>
+            <a:ext cx="2743200" cy="228600"/>
+          </a:xfrm>
+          <a:prstGeom prst="rect">
+            <a:avLst/>
+          </a:prstGeom>
+          <a:noFill/>
+          <a:ln/>
+        </p:spPr>
+        <p:txBody>
+          <a:bodyPr wrap="square" lIns="0" tIns="0" rIns="0" bIns="0" rtlCol="0" anchor="ctr"/>
+          <a:lstStyle/>
+          <a:p>
+            <a:pPr marL="0" indent="0">
+              <a:buNone/>
+            </a:pPr>
+            <a:r>
+              <a:rPr lang="en-US" sz="1300" b="1" dirty="0">
+                <a:solidFill>
+                  <a:srgbClr val="111827"/>
+                </a:solidFill>
+              </a:rPr>
+              <a:t>Main input</a:t>
+            </a:r>
+            <a:endParaRPr lang="en-US" sz="1300" dirty="0"/>
+          </a:p>
+        </p:txBody>
+      </p:sp>
+      <p:sp>
+        <p:nvSpPr>
+          <p:cNvPr id="8" name="Shape 6"/>
+          <p:cNvSpPr/>
+          <p:nvPr/>
+        </p:nvSpPr>
+        <p:spPr>
+          <a:xfrm>
+            <a:off x="914400" y="1975104"/>
+            <a:ext cx="10332720" cy="0"/>
+          </a:xfrm>
+          <a:prstGeom prst="line">
+            <a:avLst/>
+          </a:prstGeom>
+          <a:noFill/>
+          <a:ln w="7620">
+            <a:solidFill>
+              <a:srgbClr val="E5E7EB"/>
+            </a:solidFill>
+            <a:prstDash val="solid"/>
+          </a:ln>
+        </p:spPr>
+      </p:sp>
+      <p:sp>
+        <p:nvSpPr>
+          <p:cNvPr id="9" name="Text 7"/>
+          <p:cNvSpPr/>
+          <p:nvPr/>
+        </p:nvSpPr>
+        <p:spPr>
+          <a:xfrm>
+            <a:off x="941832" y="2084832"/>
+            <a:ext cx="2194560" cy="228600"/>
+          </a:xfrm>
+          <a:prstGeom prst="rect">
+            <a:avLst/>
+          </a:prstGeom>
+          <a:noFill/>
+          <a:ln/>
+        </p:spPr>
+        <p:txBody>
+          <a:bodyPr wrap="square" lIns="0" tIns="0" rIns="0" bIns="0" rtlCol="0" anchor="ctr"/>
+          <a:lstStyle/>
+          <a:p>
+            <a:pPr marL="0" indent="0">
+              <a:buNone/>
+            </a:pPr>
+            <a:r>
+              <a:rPr lang="en-US" sz="1250" b="1" dirty="0">
+                <a:solidFill>
+                  <a:srgbClr val="2563EB"/>
+                </a:solidFill>
+              </a:rPr>
+              <a:t>`search_notes`</a:t>
+            </a:r>
+            <a:endParaRPr lang="en-US" sz="1250" dirty="0"/>
+          </a:p>
+        </p:txBody>
+      </p:sp>
+      <p:sp>
+        <p:nvSpPr>
+          <p:cNvPr id="10" name="Text 8"/>
+          <p:cNvSpPr/>
+          <p:nvPr/>
+        </p:nvSpPr>
+        <p:spPr>
+          <a:xfrm>
+            <a:off x="3429000" y="2084832"/>
+            <a:ext cx="4114800" cy="228600"/>
+          </a:xfrm>
+          <a:prstGeom prst="rect">
+            <a:avLst/>
+          </a:prstGeom>
+          <a:noFill/>
+          <a:ln/>
+        </p:spPr>
+        <p:txBody>
+          <a:bodyPr wrap="square" lIns="0" tIns="0" rIns="0" bIns="0" rtlCol="0" anchor="ctr"/>
+          <a:lstStyle/>
+          <a:p>
+            <a:pPr marL="0" indent="0">
+              <a:buNone/>
+            </a:pPr>
+            <a:r>
+              <a:rPr lang="en-US" sz="1250" dirty="0">
+                <a:solidFill>
+                  <a:srgbClr val="1F2937"/>
+                </a:solidFill>
+              </a:rPr>
+              <a:t>Search local notes</a:t>
+            </a:r>
+            <a:endParaRPr lang="en-US" sz="1250" dirty="0"/>
+          </a:p>
+        </p:txBody>
+      </p:sp>
+      <p:sp>
+        <p:nvSpPr>
+          <p:cNvPr id="11" name="Text 9"/>
+          <p:cNvSpPr/>
+          <p:nvPr/>
+        </p:nvSpPr>
+        <p:spPr>
+          <a:xfrm>
+            <a:off x="8001000" y="2084832"/>
+            <a:ext cx="3017520" cy="228600"/>
+          </a:xfrm>
+          <a:prstGeom prst="rect">
+            <a:avLst/>
+          </a:prstGeom>
+          <a:noFill/>
+          <a:ln/>
+        </p:spPr>
+        <p:txBody>
+          <a:bodyPr wrap="square" lIns="0" tIns="0" rIns="0" bIns="0" rtlCol="0" anchor="ctr"/>
+          <a:lstStyle/>
+          <a:p>
+            <a:pPr marL="0" indent="0">
+              <a:buNone/>
+            </a:pPr>
+            <a:r>
+              <a:rPr lang="en-US" sz="1250" dirty="0">
+                <a:solidFill>
+                  <a:srgbClr val="1F2937"/>
+                </a:solidFill>
+              </a:rPr>
+              <a:t>query, limit</a:t>
+            </a:r>
+            <a:endParaRPr lang="en-US" sz="1250" dirty="0"/>
+          </a:p>
+        </p:txBody>
+      </p:sp>
+      <p:sp>
+        <p:nvSpPr>
+          <p:cNvPr id="12" name="Shape 10"/>
+          <p:cNvSpPr/>
+          <p:nvPr/>
+        </p:nvSpPr>
+        <p:spPr>
+          <a:xfrm>
+            <a:off x="914400" y="2606040"/>
+            <a:ext cx="10332720" cy="0"/>
+          </a:xfrm>
+          <a:prstGeom prst="line">
+            <a:avLst/>
+          </a:prstGeom>
+          <a:noFill/>
+          <a:ln w="7620">
+            <a:solidFill>
+              <a:srgbClr val="E5E7EB"/>
+            </a:solidFill>
+            <a:prstDash val="solid"/>
+          </a:ln>
+        </p:spPr>
+      </p:sp>
+      <p:sp>
+        <p:nvSpPr>
+          <p:cNvPr id="13" name="Text 11"/>
+          <p:cNvSpPr/>
+          <p:nvPr/>
+        </p:nvSpPr>
+        <p:spPr>
+          <a:xfrm>
+            <a:off x="941832" y="2715768"/>
+            <a:ext cx="2194560" cy="228600"/>
+          </a:xfrm>
+          <a:prstGeom prst="rect">
+            <a:avLst/>
+          </a:prstGeom>
+          <a:noFill/>
+          <a:ln/>
+        </p:spPr>
+        <p:txBody>
+          <a:bodyPr wrap="square" lIns="0" tIns="0" rIns="0" bIns="0" rtlCol="0" anchor="ctr"/>
+          <a:lstStyle/>
+          <a:p>
+            <a:pPr marL="0" indent="0">
+              <a:buNone/>
+            </a:pPr>
+            <a:r>
+              <a:rPr lang="en-US" sz="1250" b="1" dirty="0">
+                <a:solidFill>
+                  <a:srgbClr val="2563EB"/>
+                </a:solidFill>
+              </a:rPr>
+              <a:t>`search_faqs`</a:t>
+            </a:r>
+            <a:endParaRPr lang="en-US" sz="1250" dirty="0"/>
+          </a:p>
+        </p:txBody>
+      </p:sp>
+      <p:sp>
+        <p:nvSpPr>
+          <p:cNvPr id="14" name="Text 12"/>
+          <p:cNvSpPr/>
+          <p:nvPr/>
+        </p:nvSpPr>
+        <p:spPr>
+          <a:xfrm>
+            <a:off x="3429000" y="2715768"/>
+            <a:ext cx="4114800" cy="228600"/>
+          </a:xfrm>
+          <a:prstGeom prst="rect">
+            <a:avLst/>
+          </a:prstGeom>
+          <a:noFill/>
+          <a:ln/>
+        </p:spPr>
+        <p:txBody>
+          <a:bodyPr wrap="square" lIns="0" tIns="0" rIns="0" bIns="0" rtlCol="0" anchor="ctr"/>
+          <a:lstStyle/>
+          <a:p>
+            <a:pPr marL="0" indent="0">
+              <a:buNone/>
+            </a:pPr>
+            <a:r>
+              <a:rPr lang="en-US" sz="1250" dirty="0">
+                <a:solidFill>
+                  <a:srgbClr val="1F2937"/>
+                </a:solidFill>
+              </a:rPr>
+              <a:t>Search FAQ entries</a:t>
+            </a:r>
+            <a:endParaRPr lang="en-US" sz="1250" dirty="0"/>
+          </a:p>
+        </p:txBody>
+      </p:sp>
+      <p:sp>
+        <p:nvSpPr>
+          <p:cNvPr id="15" name="Text 13"/>
+          <p:cNvSpPr/>
+          <p:nvPr/>
+        </p:nvSpPr>
+        <p:spPr>
+          <a:xfrm>
+            <a:off x="8001000" y="2715768"/>
+            <a:ext cx="3017520" cy="228600"/>
+          </a:xfrm>
+          <a:prstGeom prst="rect">
+            <a:avLst/>
+          </a:prstGeom>
+          <a:noFill/>
+          <a:ln/>
+        </p:spPr>
+        <p:txBody>
+          <a:bodyPr wrap="square" lIns="0" tIns="0" rIns="0" bIns="0" rtlCol="0" anchor="ctr"/>
+          <a:lstStyle/>
+          <a:p>
+            <a:pPr marL="0" indent="0">
+              <a:buNone/>
+            </a:pPr>
+            <a:r>
+              <a:rPr lang="en-US" sz="1250" dirty="0">
+                <a:solidFill>
+                  <a:srgbClr val="1F2937"/>
+                </a:solidFill>
+              </a:rPr>
+              <a:t>query, limit</a:t>
+            </a:r>
+            <a:endParaRPr lang="en-US" sz="1250" dirty="0"/>
+          </a:p>
+        </p:txBody>
+      </p:sp>
+      <p:sp>
+        <p:nvSpPr>
+          <p:cNvPr id="16" name="Shape 14"/>
+          <p:cNvSpPr/>
+          <p:nvPr/>
+        </p:nvSpPr>
+        <p:spPr>
+          <a:xfrm>
+            <a:off x="914400" y="3236976"/>
+            <a:ext cx="10332720" cy="0"/>
+          </a:xfrm>
+          <a:prstGeom prst="line">
+            <a:avLst/>
+          </a:prstGeom>
+          <a:noFill/>
+          <a:ln w="7620">
+            <a:solidFill>
+              <a:srgbClr val="E5E7EB"/>
+            </a:solidFill>
+            <a:prstDash val="solid"/>
+          </a:ln>
+        </p:spPr>
+      </p:sp>
+      <p:sp>
+        <p:nvSpPr>
+          <p:cNvPr id="17" name="Text 15"/>
+          <p:cNvSpPr/>
+          <p:nvPr/>
+        </p:nvSpPr>
+        <p:spPr>
+          <a:xfrm>
+            <a:off x="941832" y="3346704"/>
+            <a:ext cx="2194560" cy="228600"/>
+          </a:xfrm>
+          <a:prstGeom prst="rect">
+            <a:avLst/>
+          </a:prstGeom>
+          <a:noFill/>
+          <a:ln/>
+        </p:spPr>
+        <p:txBody>
+          <a:bodyPr wrap="square" lIns="0" tIns="0" rIns="0" bIns="0" rtlCol="0" anchor="ctr"/>
+          <a:lstStyle/>
+          <a:p>
+            <a:pPr marL="0" indent="0">
+              <a:buNone/>
+            </a:pPr>
+            <a:r>
+              <a:rPr lang="en-US" sz="1250" b="1" dirty="0">
+                <a:solidFill>
+                  <a:srgbClr val="2563EB"/>
+                </a:solidFill>
+              </a:rPr>
+              <a:t>`get_note`</a:t>
+            </a:r>
+            <a:endParaRPr lang="en-US" sz="1250" dirty="0"/>
+          </a:p>
+        </p:txBody>
+      </p:sp>
+      <p:sp>
+        <p:nvSpPr>
+          <p:cNvPr id="18" name="Text 16"/>
+          <p:cNvSpPr/>
+          <p:nvPr/>
+        </p:nvSpPr>
+        <p:spPr>
+          <a:xfrm>
+            <a:off x="3429000" y="3346704"/>
+            <a:ext cx="4114800" cy="228600"/>
+          </a:xfrm>
+          <a:prstGeom prst="rect">
+            <a:avLst/>
+          </a:prstGeom>
+          <a:noFill/>
+          <a:ln/>
+        </p:spPr>
+        <p:txBody>
+          <a:bodyPr wrap="square" lIns="0" tIns="0" rIns="0" bIns="0" rtlCol="0" anchor="ctr"/>
+          <a:lstStyle/>
+          <a:p>
+            <a:pPr marL="0" indent="0">
+              <a:buNone/>
+            </a:pPr>
+            <a:r>
+              <a:rPr lang="en-US" sz="1250" dirty="0">
+                <a:solidFill>
+                  <a:srgbClr val="1F2937"/>
+                </a:solidFill>
+              </a:rPr>
+              <a:t>Retrieve one note</a:t>
+            </a:r>
+            <a:endParaRPr lang="en-US" sz="1250" dirty="0"/>
+          </a:p>
+        </p:txBody>
+      </p:sp>
+      <p:sp>
+        <p:nvSpPr>
+          <p:cNvPr id="19" name="Text 17"/>
+          <p:cNvSpPr/>
+          <p:nvPr/>
+        </p:nvSpPr>
+        <p:spPr>
+          <a:xfrm>
+            <a:off x="8001000" y="3346704"/>
+            <a:ext cx="3017520" cy="228600"/>
+          </a:xfrm>
+          <a:prstGeom prst="rect">
+            <a:avLst/>
+          </a:prstGeom>
+          <a:noFill/>
+          <a:ln/>
+        </p:spPr>
+        <p:txBody>
+          <a:bodyPr wrap="square" lIns="0" tIns="0" rIns="0" bIns="0" rtlCol="0" anchor="ctr"/>
+          <a:lstStyle/>
+          <a:p>
+            <a:pPr marL="0" indent="0">
+              <a:buNone/>
+            </a:pPr>
+            <a:r>
+              <a:rPr lang="en-US" sz="1250" dirty="0">
+                <a:solidFill>
+                  <a:srgbClr val="1F2937"/>
+                </a:solidFill>
+              </a:rPr>
+              <a:t>note_id</a:t>
+            </a:r>
+            <a:endParaRPr lang="en-US" sz="1250" dirty="0"/>
+          </a:p>
+        </p:txBody>
+      </p:sp>
+      <p:sp>
+        <p:nvSpPr>
+          <p:cNvPr id="20" name="Shape 18"/>
+          <p:cNvSpPr/>
+          <p:nvPr/>
+        </p:nvSpPr>
+        <p:spPr>
+          <a:xfrm>
+            <a:off x="914400" y="3867912"/>
+            <a:ext cx="10332720" cy="0"/>
+          </a:xfrm>
+          <a:prstGeom prst="line">
+            <a:avLst/>
+          </a:prstGeom>
+          <a:noFill/>
+          <a:ln w="7620">
+            <a:solidFill>
+              <a:srgbClr val="E5E7EB"/>
+            </a:solidFill>
+            <a:prstDash val="solid"/>
+          </a:ln>
+        </p:spPr>
+      </p:sp>
+      <p:sp>
+        <p:nvSpPr>
+          <p:cNvPr id="21" name="Text 19"/>
+          <p:cNvSpPr/>
+          <p:nvPr/>
+        </p:nvSpPr>
+        <p:spPr>
+          <a:xfrm>
+            <a:off x="941832" y="3977640"/>
+            <a:ext cx="2194560" cy="228600"/>
+          </a:xfrm>
+          <a:prstGeom prst="rect">
+            <a:avLst/>
+          </a:prstGeom>
+          <a:noFill/>
+          <a:ln/>
+        </p:spPr>
+        <p:txBody>
+          <a:bodyPr wrap="square" lIns="0" tIns="0" rIns="0" bIns="0" rtlCol="0" anchor="ctr"/>
+          <a:lstStyle/>
+          <a:p>
+            <a:pPr marL="0" indent="0">
+              <a:buNone/>
+            </a:pPr>
+            <a:r>
+              <a:rPr lang="en-US" sz="1250" b="1" dirty="0">
+                <a:solidFill>
+                  <a:srgbClr val="2563EB"/>
+                </a:solidFill>
+              </a:rPr>
+              <a:t>`list_notes`</a:t>
+            </a:r>
+            <a:endParaRPr lang="en-US" sz="1250" dirty="0"/>
+          </a:p>
+        </p:txBody>
+      </p:sp>
+      <p:sp>
+        <p:nvSpPr>
+          <p:cNvPr id="22" name="Text 20"/>
+          <p:cNvSpPr/>
+          <p:nvPr/>
+        </p:nvSpPr>
+        <p:spPr>
+          <a:xfrm>
+            <a:off x="3429000" y="3977640"/>
+            <a:ext cx="4114800" cy="228600"/>
+          </a:xfrm>
+          <a:prstGeom prst="rect">
+            <a:avLst/>
+          </a:prstGeom>
+          <a:noFill/>
+          <a:ln/>
+        </p:spPr>
+        <p:txBody>
+          <a:bodyPr wrap="square" lIns="0" tIns="0" rIns="0" bIns="0" rtlCol="0" anchor="ctr"/>
+          <a:lstStyle/>
+          <a:p>
+            <a:pPr marL="0" indent="0">
+              <a:buNone/>
+            </a:pPr>
+            <a:r>
+              <a:rPr lang="en-US" sz="1250" dirty="0">
+                <a:solidFill>
+                  <a:srgbClr val="1F2937"/>
+                </a:solidFill>
+              </a:rPr>
+              <a:t>Browse notes</a:t>
+            </a:r>
+            <a:endParaRPr lang="en-US" sz="1250" dirty="0"/>
+          </a:p>
+        </p:txBody>
+      </p:sp>
+      <p:sp>
+        <p:nvSpPr>
+          <p:cNvPr id="23" name="Text 21"/>
+          <p:cNvSpPr/>
+          <p:nvPr/>
+        </p:nvSpPr>
+        <p:spPr>
+          <a:xfrm>
+            <a:off x="8001000" y="3977640"/>
+            <a:ext cx="3017520" cy="228600"/>
+          </a:xfrm>
+          <a:prstGeom prst="rect">
+            <a:avLst/>
+          </a:prstGeom>
+          <a:noFill/>
+          <a:ln/>
+        </p:spPr>
+        <p:txBody>
+          <a:bodyPr wrap="square" lIns="0" tIns="0" rIns="0" bIns="0" rtlCol="0" anchor="ctr"/>
+          <a:lstStyle/>
+          <a:p>
+            <a:pPr marL="0" indent="0">
+              <a:buNone/>
+            </a:pPr>
+            <a:r>
+              <a:rPr lang="en-US" sz="1250" dirty="0">
+                <a:solidFill>
+                  <a:srgbClr val="1F2937"/>
+                </a:solidFill>
+              </a:rPr>
+              <a:t>tag, limit</a:t>
+            </a:r>
+            <a:endParaRPr lang="en-US" sz="1250" dirty="0"/>
+          </a:p>
+        </p:txBody>
+      </p:sp>
+      <p:sp>
+        <p:nvSpPr>
+          <p:cNvPr id="24" name="Shape 22"/>
+          <p:cNvSpPr/>
+          <p:nvPr/>
+        </p:nvSpPr>
+        <p:spPr>
+          <a:xfrm>
+            <a:off x="914400" y="4498848"/>
+            <a:ext cx="10332720" cy="0"/>
+          </a:xfrm>
+          <a:prstGeom prst="line">
+            <a:avLst/>
+          </a:prstGeom>
+          <a:noFill/>
+          <a:ln w="7620">
+            <a:solidFill>
+              <a:srgbClr val="E5E7EB"/>
+            </a:solidFill>
+            <a:prstDash val="solid"/>
+          </a:ln>
+        </p:spPr>
+      </p:sp>
+      <p:sp>
+        <p:nvSpPr>
+          <p:cNvPr id="25" name="Text 23"/>
+          <p:cNvSpPr/>
+          <p:nvPr/>
+        </p:nvSpPr>
+        <p:spPr>
+          <a:xfrm>
+            <a:off x="941832" y="4608576"/>
+            <a:ext cx="2194560" cy="228600"/>
+          </a:xfrm>
+          <a:prstGeom prst="rect">
+            <a:avLst/>
+          </a:prstGeom>
+          <a:noFill/>
+          <a:ln/>
+        </p:spPr>
+        <p:txBody>
+          <a:bodyPr wrap="square" lIns="0" tIns="0" rIns="0" bIns="0" rtlCol="0" anchor="ctr"/>
+          <a:lstStyle/>
+          <a:p>
+            <a:pPr marL="0" indent="0">
+              <a:buNone/>
+            </a:pPr>
+            <a:r>
+              <a:rPr lang="en-US" sz="1250" b="1" dirty="0">
+                <a:solidFill>
+                  <a:srgbClr val="2563EB"/>
+                </a:solidFill>
+              </a:rPr>
+              <a:t>`add_note`</a:t>
+            </a:r>
+            <a:endParaRPr lang="en-US" sz="1250" dirty="0"/>
+          </a:p>
+        </p:txBody>
+      </p:sp>
+      <p:sp>
+        <p:nvSpPr>
+          <p:cNvPr id="26" name="Text 24"/>
+          <p:cNvSpPr/>
+          <p:nvPr/>
+        </p:nvSpPr>
+        <p:spPr>
+          <a:xfrm>
+            <a:off x="3429000" y="4608576"/>
+            <a:ext cx="4114800" cy="228600"/>
+          </a:xfrm>
+          <a:prstGeom prst="rect">
+            <a:avLst/>
+          </a:prstGeom>
+          <a:noFill/>
+          <a:ln/>
+        </p:spPr>
+        <p:txBody>
+          <a:bodyPr wrap="square" lIns="0" tIns="0" rIns="0" bIns="0" rtlCol="0" anchor="ctr"/>
+          <a:lstStyle/>
+          <a:p>
+            <a:pPr marL="0" indent="0">
+              <a:buNone/>
+            </a:pPr>
+            <a:r>
+              <a:rPr lang="en-US" sz="1250" dirty="0">
+                <a:solidFill>
+                  <a:srgbClr val="1F2937"/>
+                </a:solidFill>
+              </a:rPr>
+              <a:t>Safely add a local note</a:t>
+            </a:r>
+            <a:endParaRPr lang="en-US" sz="1250" dirty="0"/>
+          </a:p>
+        </p:txBody>
+      </p:sp>
+      <p:sp>
+        <p:nvSpPr>
+          <p:cNvPr id="27" name="Text 25"/>
+          <p:cNvSpPr/>
+          <p:nvPr/>
+        </p:nvSpPr>
+        <p:spPr>
+          <a:xfrm>
+            <a:off x="8001000" y="4608576"/>
+            <a:ext cx="3017520" cy="228600"/>
+          </a:xfrm>
+          <a:prstGeom prst="rect">
+            <a:avLst/>
+          </a:prstGeom>
+          <a:noFill/>
+          <a:ln/>
+        </p:spPr>
+        <p:txBody>
+          <a:bodyPr wrap="square" lIns="0" tIns="0" rIns="0" bIns="0" rtlCol="0" anchor="ctr"/>
+          <a:lstStyle/>
+          <a:p>
+            <a:pPr marL="0" indent="0">
+              <a:buNone/>
+            </a:pPr>
+            <a:r>
+              <a:rPr lang="en-US" sz="1250" dirty="0">
+                <a:solidFill>
+                  <a:srgbClr val="1F2937"/>
+                </a:solidFill>
+              </a:rPr>
+              <a:t>title, content, tags</a:t>
+            </a:r>
+            <a:endParaRPr lang="en-US" sz="1250" dirty="0"/>
+          </a:p>
+        </p:txBody>
+      </p:sp>
+      <p:sp>
+        <p:nvSpPr>
+          <p:cNvPr id="28" name="Shape 26"/>
+          <p:cNvSpPr/>
+          <p:nvPr/>
+        </p:nvSpPr>
+        <p:spPr>
+          <a:xfrm>
+            <a:off x="868680" y="5806440"/>
+            <a:ext cx="1920240" cy="365760"/>
+          </a:xfrm>
+          <a:prstGeom prst="roundRect">
+            <a:avLst>
+              <a:gd name="adj" fmla="val 20000"/>
+            </a:avLst>
+          </a:prstGeom>
+          <a:solidFill>
+            <a:srgbClr val="DCFCE7"/>
+          </a:solidFill>
+          <a:ln w="12700">
+            <a:solidFill>
+              <a:srgbClr val="DCFCE7"/>
+            </a:solidFill>
+            <a:prstDash val="solid"/>
+          </a:ln>
+        </p:spPr>
+      </p:sp>
+      <p:sp>
+        <p:nvSpPr>
+          <p:cNvPr id="29" name="Text 27"/>
+          <p:cNvSpPr/>
+          <p:nvPr/>
+        </p:nvSpPr>
+        <p:spPr>
+          <a:xfrm>
+            <a:off x="960120" y="5902452"/>
+            <a:ext cx="1737360" cy="146304"/>
+          </a:xfrm>
+          <a:prstGeom prst="rect">
+            <a:avLst/>
+          </a:prstGeom>
+          <a:noFill/>
+          <a:ln/>
+        </p:spPr>
+        <p:txBody>
+          <a:bodyPr wrap="square" lIns="0" tIns="0" rIns="0" bIns="0" rtlCol="0" anchor="ctr"/>
+          <a:lstStyle/>
+          <a:p>
+            <a:pPr marL="0" indent="0" algn="ctr">
+              <a:buNone/>
+            </a:pPr>
+            <a:r>
+              <a:rPr lang="en-US" sz="1050" b="1" dirty="0">
+                <a:solidFill>
+                  <a:srgbClr val="111827"/>
+                </a:solidFill>
+              </a:rPr>
+              <a:t>Live demo: search_notes</a:t>
+            </a:r>
+            <a:endParaRPr lang="en-US" sz="1050" dirty="0"/>
+          </a:p>
+        </p:txBody>
+      </p:sp>
+      <p:sp>
+        <p:nvSpPr>
+          <p:cNvPr id="30" name="Shape 28"/>
+          <p:cNvSpPr/>
+          <p:nvPr/>
+        </p:nvSpPr>
+        <p:spPr>
+          <a:xfrm>
+            <a:off x="3017520" y="5806440"/>
+            <a:ext cx="1691640" cy="365760"/>
+          </a:xfrm>
+          <a:prstGeom prst="roundRect">
+            <a:avLst>
+              <a:gd name="adj" fmla="val 20000"/>
+            </a:avLst>
+          </a:prstGeom>
+          <a:solidFill>
+            <a:srgbClr val="DCFCE7"/>
+          </a:solidFill>
+          <a:ln w="12700">
+            <a:solidFill>
+              <a:srgbClr val="DCFCE7"/>
+            </a:solidFill>
+            <a:prstDash val="solid"/>
+          </a:ln>
+        </p:spPr>
+      </p:sp>
+      <p:sp>
+        <p:nvSpPr>
+          <p:cNvPr id="31" name="Text 29"/>
+          <p:cNvSpPr/>
+          <p:nvPr/>
+        </p:nvSpPr>
+        <p:spPr>
+          <a:xfrm>
+            <a:off x="3108960" y="5902452"/>
+            <a:ext cx="1508760" cy="146304"/>
+          </a:xfrm>
+          <a:prstGeom prst="rect">
+            <a:avLst/>
+          </a:prstGeom>
+          <a:noFill/>
+          <a:ln/>
+        </p:spPr>
+        <p:txBody>
+          <a:bodyPr wrap="square" lIns="0" tIns="0" rIns="0" bIns="0" rtlCol="0" anchor="ctr"/>
+          <a:lstStyle/>
+          <a:p>
+            <a:pPr marL="0" indent="0" algn="ctr">
+              <a:buNone/>
+            </a:pPr>
+            <a:r>
+              <a:rPr lang="en-US" sz="1050" b="1" dirty="0">
+                <a:solidFill>
+                  <a:srgbClr val="111827"/>
+                </a:solidFill>
+              </a:rPr>
+              <a:t>Live demo: get_note</a:t>
+            </a:r>
+            <a:endParaRPr lang="en-US" sz="1050" dirty="0"/>
+          </a:p>
+        </p:txBody>
+      </p:sp>
+      <p:sp>
+        <p:nvSpPr>
+          <p:cNvPr id="32" name="Text 30"/>
+          <p:cNvSpPr/>
+          <p:nvPr/>
+        </p:nvSpPr>
+        <p:spPr>
+          <a:xfrm>
+            <a:off x="502920" y="6455664"/>
+            <a:ext cx="2743200" cy="182880"/>
+          </a:xfrm>
+          <a:prstGeom prst="rect">
+            <a:avLst/>
+          </a:prstGeom>
+          <a:noFill/>
+          <a:ln/>
+        </p:spPr>
+        <p:txBody>
+          <a:bodyPr wrap="square" rtlCol="0" anchor="ctr"/>
+          <a:lstStyle/>
+          <a:p>
+            <a:pPr marL="0" indent="0">
+              <a:buNone/>
+            </a:pPr>
+            <a:r>
+              <a:rPr lang="en-US" sz="900" dirty="0">
+                <a:solidFill>
+                  <a:srgbClr val="6B7280"/>
+                </a:solidFill>
+              </a:rPr>
+              <a:t>Task 6.3 Demo | 4/5</a:t>
+            </a:r>
+            <a:endParaRPr lang="en-US" sz="900" dirty="0"/>
+          </a:p>
+        </p:txBody>
+      </p:sp>
+    </p:spTree>
+  </p:cSld>
+  <p:clrMapOvr>
+    <a:masterClrMapping/>
+  </p:clrMapOvr>
+</p:sld>
+</file>
+
+<file path=ppt/slides/slide5.xml><?xml version="1.0" encoding="utf-8"?>
+<p:sld xmlns:a="http://schemas.openxmlformats.org/drawingml/2006/main" xmlns:r="http://schemas.openxmlformats.org/officeDocument/2006/relationships" xmlns:p="http://schemas.openxmlformats.org/presentationml/2006/main">
+  <p:cSld name="Slide 5">
+    <p:bg>
+      <p:bgPr>
+        <a:solidFill>
+          <a:srgbClr val="F8FAFC"/>
+        </a:solidFill>
+        <a:effectLst/>
+      </p:bgPr>
+    </p:bg>
+    <p:spTree>
+      <p:nvGrpSpPr>
+        <p:cNvPr id="1" name=""/>
+        <p:cNvGrpSpPr/>
+        <p:nvPr/>
+      </p:nvGrpSpPr>
+      <p:grpSpPr>
+        <a:xfrm>
+          <a:off x="0" y="0"/>
+          <a:ext cx="0" cy="0"/>
+          <a:chOff x="0" y="0"/>
+          <a:chExt cx="0" cy="0"/>
+        </a:xfrm>
+      </p:grpSpPr>
+      <p:sp>
+        <p:nvSpPr>
+          <p:cNvPr id="2" name="Text 0"/>
+          <p:cNvSpPr/>
+          <p:nvPr/>
+        </p:nvSpPr>
+        <p:spPr>
+          <a:xfrm>
+            <a:off x="502920" y="320040"/>
+            <a:ext cx="7772400" cy="411480"/>
+          </a:xfrm>
+          <a:prstGeom prst="rect">
+            <a:avLst/>
+          </a:prstGeom>
+          <a:noFill/>
+          <a:ln/>
+        </p:spPr>
+        <p:txBody>
+          <a:bodyPr wrap="square" lIns="0" tIns="0" rIns="0" bIns="0" rtlCol="0" anchor="ctr"/>
+          <a:lstStyle/>
+          <a:p>
+            <a:pPr marL="0" indent="0">
+              <a:buNone/>
+            </a:pPr>
+            <a:r>
+              <a:rPr lang="en-US" sz="2800" b="1" dirty="0">
+                <a:solidFill>
+                  <a:srgbClr val="111827"/>
+                </a:solidFill>
+              </a:rPr>
+              <a:t>Next steps &amp; backup plan</a:t>
+            </a:r>
+            <a:endParaRPr lang="en-US" sz="2800" dirty="0"/>
+          </a:p>
+        </p:txBody>
+      </p:sp>
+      <p:sp>
+        <p:nvSpPr>
+          <p:cNvPr id="3" name="Text 1"/>
+          <p:cNvSpPr/>
+          <p:nvPr/>
+        </p:nvSpPr>
+        <p:spPr>
+          <a:xfrm>
+            <a:off x="502920" y="822960"/>
+            <a:ext cx="8595360" cy="274320"/>
+          </a:xfrm>
+          <a:prstGeom prst="rect">
+            <a:avLst/>
+          </a:prstGeom>
+          <a:noFill/>
+          <a:ln/>
+        </p:spPr>
+        <p:txBody>
+          <a:bodyPr wrap="square" lIns="0" tIns="0" rIns="0" bIns="0" rtlCol="0" anchor="ctr"/>
+          <a:lstStyle/>
+          <a:p>
+            <a:pPr marL="0" indent="0">
+              <a:buNone/>
+            </a:pPr>
+            <a:r>
+              <a:rPr lang="en-US" sz="1400" dirty="0">
+                <a:solidFill>
+                  <a:srgbClr val="6B7280"/>
+                </a:solidFill>
+              </a:rPr>
+              <a:t>Keep the demo timeboxed and switch to offline evidence if the live setup fails.</a:t>
+            </a:r>
+            <a:endParaRPr lang="en-US" sz="1400" dirty="0"/>
+          </a:p>
+        </p:txBody>
+      </p:sp>
+      <p:sp>
+        <p:nvSpPr>
+          <p:cNvPr id="4" name="Shape 2"/>
+          <p:cNvSpPr/>
+          <p:nvPr/>
+        </p:nvSpPr>
+        <p:spPr>
+          <a:xfrm>
+            <a:off x="685800" y="1417320"/>
+            <a:ext cx="4937760" cy="3200400"/>
+          </a:xfrm>
+          <a:prstGeom prst="roundRect">
+            <a:avLst>
+              <a:gd name="adj" fmla="val 2571"/>
+            </a:avLst>
+          </a:prstGeom>
+          <a:solidFill>
+            <a:srgbClr val="FFFFFF"/>
+          </a:solidFill>
+          <a:ln w="12700">
+            <a:solidFill>
+              <a:srgbClr val="E5E7EB"/>
+            </a:solidFill>
+            <a:prstDash val="solid"/>
+          </a:ln>
+        </p:spPr>
+      </p:sp>
+      <p:sp>
+        <p:nvSpPr>
+          <p:cNvPr id="5" name="Text 3"/>
+          <p:cNvSpPr/>
+          <p:nvPr/>
+        </p:nvSpPr>
+        <p:spPr>
+          <a:xfrm>
+            <a:off x="886968" y="1600200"/>
+            <a:ext cx="4535424" cy="237744"/>
+          </a:xfrm>
+          <a:prstGeom prst="rect">
+            <a:avLst/>
+          </a:prstGeom>
+          <a:noFill/>
+          <a:ln/>
+        </p:spPr>
+        <p:txBody>
+          <a:bodyPr wrap="square" lIns="0" tIns="0" rIns="0" bIns="0" rtlCol="0" anchor="ctr"/>
+          <a:lstStyle/>
+          <a:p>
+            <a:pPr marL="0" indent="0">
+              <a:buNone/>
+            </a:pPr>
+            <a:r>
+              <a:rPr lang="en-US" sz="1500" b="1" dirty="0">
+                <a:solidFill>
+                  <a:srgbClr val="111827"/>
+                </a:solidFill>
+              </a:rPr>
+              <a:t>Next steps</a:t>
+            </a:r>
+            <a:endParaRPr lang="en-US" sz="1500" dirty="0"/>
+          </a:p>
+        </p:txBody>
+      </p:sp>
+      <p:sp>
+        <p:nvSpPr>
+          <p:cNvPr id="6" name="Text 4"/>
+          <p:cNvSpPr/>
+          <p:nvPr/>
+        </p:nvSpPr>
+        <p:spPr>
+          <a:xfrm>
+            <a:off x="886968" y="1984248"/>
+            <a:ext cx="4535424" cy="2468880"/>
+          </a:xfrm>
+          <a:prstGeom prst="rect">
+            <a:avLst/>
+          </a:prstGeom>
+          <a:noFill/>
+          <a:ln/>
+        </p:spPr>
+        <p:txBody>
+          <a:bodyPr wrap="square" lIns="0" tIns="0" rIns="0" bIns="0" rtlCol="0" anchor="ctr">
+            <a:normAutofit/>
+          </a:bodyPr>
+          <a:lstStyle/>
+          <a:p>
+            <a:pPr marL="0" indent="0">
+              <a:buNone/>
+            </a:pPr>
+            <a:r>
+              <a:rPr lang="en-US" sz="1180" dirty="0">
+                <a:solidFill>
+                  <a:srgbClr val="1F2937"/>
+                </a:solidFill>
+              </a:rPr>
+              <a:t>Add a short recorded walkthrough, expand fixture examples, and improve common prompt examples while keeping the server offline and focused.</a:t>
+            </a:r>
+            <a:endParaRPr lang="en-US" sz="1180" dirty="0"/>
+          </a:p>
+        </p:txBody>
+      </p:sp>
+      <p:sp>
+        <p:nvSpPr>
+          <p:cNvPr id="7" name="Shape 5"/>
+          <p:cNvSpPr/>
+          <p:nvPr/>
+        </p:nvSpPr>
+        <p:spPr>
+          <a:xfrm>
+            <a:off x="6400800" y="1417320"/>
+            <a:ext cx="4937760" cy="3200400"/>
+          </a:xfrm>
+          <a:prstGeom prst="roundRect">
+            <a:avLst>
+              <a:gd name="adj" fmla="val 2571"/>
+            </a:avLst>
+          </a:prstGeom>
+          <a:solidFill>
+            <a:srgbClr val="FFFFFF"/>
+          </a:solidFill>
+          <a:ln w="12700">
+            <a:solidFill>
+              <a:srgbClr val="E5E7EB"/>
+            </a:solidFill>
+            <a:prstDash val="solid"/>
+          </a:ln>
+        </p:spPr>
+      </p:sp>
+      <p:sp>
+        <p:nvSpPr>
+          <p:cNvPr id="8" name="Text 6"/>
+          <p:cNvSpPr/>
+          <p:nvPr/>
+        </p:nvSpPr>
+        <p:spPr>
+          <a:xfrm>
+            <a:off x="6601968" y="1600200"/>
+            <a:ext cx="4535424" cy="237744"/>
+          </a:xfrm>
+          <a:prstGeom prst="rect">
+            <a:avLst/>
+          </a:prstGeom>
+          <a:noFill/>
+          <a:ln/>
+        </p:spPr>
+        <p:txBody>
+          <a:bodyPr wrap="square" lIns="0" tIns="0" rIns="0" bIns="0" rtlCol="0" anchor="ctr"/>
+          <a:lstStyle/>
+          <a:p>
+            <a:pPr marL="0" indent="0">
+              <a:buNone/>
+            </a:pPr>
+            <a:r>
+              <a:rPr lang="en-US" sz="1500" b="1" dirty="0">
+                <a:solidFill>
+                  <a:srgbClr val="111827"/>
+                </a:solidFill>
+              </a:rPr>
+              <a:t>Backup plan</a:t>
+            </a:r>
+            <a:endParaRPr lang="en-US" sz="1500" dirty="0"/>
+          </a:p>
+        </p:txBody>
+      </p:sp>
+      <p:sp>
+        <p:nvSpPr>
+          <p:cNvPr id="9" name="Text 7"/>
+          <p:cNvSpPr/>
+          <p:nvPr/>
+        </p:nvSpPr>
+        <p:spPr>
+          <a:xfrm>
+            <a:off x="6601968" y="1984248"/>
+            <a:ext cx="4535424" cy="2468880"/>
+          </a:xfrm>
+          <a:prstGeom prst="rect">
+            <a:avLst/>
+          </a:prstGeom>
+          <a:noFill/>
+          <a:ln/>
+        </p:spPr>
+        <p:txBody>
+          <a:bodyPr wrap="square" lIns="0" tIns="0" rIns="0" bIns="0" rtlCol="0" anchor="ctr">
+            <a:normAutofit/>
+          </a:bodyPr>
+          <a:lstStyle/>
+          <a:p>
+            <a:pPr marL="0" indent="0">
+              <a:buNone/>
+            </a:pPr>
+            <a:r>
+              <a:rPr lang="en-US" sz="1180" dirty="0">
+                <a:solidFill>
+                  <a:srgbClr val="1F2937"/>
+                </a:solidFill>
+              </a:rPr>
+              <a:t>If Wi-Fi fails, use the installed local clone and MCP Inspector. If the host fails, show fresh-clone screenshots from v1.0.0.</a:t>
+            </a:r>
+            <a:endParaRPr lang="en-US" sz="1180" dirty="0"/>
+          </a:p>
+        </p:txBody>
+      </p:sp>
+      <p:sp>
+        <p:nvSpPr>
+          <p:cNvPr id="10" name="Text 8"/>
+          <p:cNvSpPr/>
+          <p:nvPr/>
+        </p:nvSpPr>
+        <p:spPr>
+          <a:xfrm>
+            <a:off x="685800" y="5486400"/>
+            <a:ext cx="4754880" cy="365760"/>
+          </a:xfrm>
+          <a:prstGeom prst="rect">
+            <a:avLst/>
+          </a:prstGeom>
+          <a:noFill/>
+          <a:ln/>
+        </p:spPr>
+        <p:txBody>
+          <a:bodyPr wrap="square" lIns="0" tIns="0" rIns="0" bIns="0" rtlCol="0" anchor="ctr"/>
+          <a:lstStyle/>
+          <a:p>
+            <a:pPr marL="0" indent="0">
+              <a:buNone/>
+            </a:pPr>
+            <a:r>
+              <a:rPr lang="en-US" sz="2300" b="1" dirty="0">
+                <a:solidFill>
+                  <a:srgbClr val="16A34A"/>
+                </a:solidFill>
+              </a:rPr>
+              <a:t>Ready for questions</a:t>
+            </a:r>
+            <a:endParaRPr lang="en-US" sz="2300" dirty="0"/>
+          </a:p>
+        </p:txBody>
+      </p:sp>
+      <p:sp>
+        <p:nvSpPr>
+          <p:cNvPr id="11" name="Text 9"/>
+          <p:cNvSpPr/>
+          <p:nvPr/>
+        </p:nvSpPr>
+        <p:spPr>
+          <a:xfrm>
+            <a:off x="685800" y="5897880"/>
+            <a:ext cx="8046720" cy="237744"/>
+          </a:xfrm>
+          <a:prstGeom prst="rect">
+            <a:avLst/>
+          </a:prstGeom>
+          <a:noFill/>
+          <a:ln/>
+        </p:spPr>
+        <p:txBody>
+          <a:bodyPr wrap="square" lIns="0" tIns="0" rIns="0" bIns="0" rtlCol="0" anchor="ctr"/>
+          <a:lstStyle/>
+          <a:p>
+            <a:pPr marL="0" indent="0">
+              <a:buNone/>
+            </a:pPr>
+            <a:r>
+              <a:rPr lang="en-US" sz="1300" dirty="0">
+                <a:solidFill>
+                  <a:srgbClr val="6B7280"/>
+                </a:solidFill>
+              </a:rPr>
+              <a:t>Public repo + final main + v1.0.0 release + Inspector evidence</a:t>
+            </a:r>
+            <a:endParaRPr lang="en-US" sz="1300" dirty="0"/>
+          </a:p>
+        </p:txBody>
+      </p:sp>
+      <p:sp>
+        <p:nvSpPr>
+          <p:cNvPr id="12" name="Text 10"/>
+          <p:cNvSpPr/>
+          <p:nvPr/>
+        </p:nvSpPr>
+        <p:spPr>
+          <a:xfrm>
+            <a:off x="502920" y="6455664"/>
+            <a:ext cx="2743200" cy="182880"/>
+          </a:xfrm>
+          <a:prstGeom prst="rect">
+            <a:avLst/>
+          </a:prstGeom>
+          <a:noFill/>
+          <a:ln/>
+        </p:spPr>
+        <p:txBody>
+          <a:bodyPr wrap="square" rtlCol="0" anchor="ctr"/>
+          <a:lstStyle/>
+          <a:p>
+            <a:pPr marL="0" indent="0">
+              <a:buNone/>
+            </a:pPr>
+            <a:r>
+              <a:rPr lang="en-US" sz="900" dirty="0">
+                <a:solidFill>
+                  <a:srgbClr val="6B7280"/>
+                </a:solidFill>
+              </a:rPr>
+              <a:t>Task 6.3 Demo | 5/5</a:t>
             </a:r>
             <a:endParaRPr lang="en-US" sz="900" dirty="0"/>
           </a:p>
@@ -3017,7 +4418,7 @@
   <a:extraClrSchemeLst/>
   <a:extLst>
     <a:ext uri="{05A4C25C-085E-4340-85A3-A5531E510DB2}">
-      <thm15:themeFamily xmlns:thm15="http://schemas.microsoft.com/office/thememl/2012/main" xmlns="" name="Office Theme" id="{62F939B6-93AF-4DB8-9C6B-D6C7DFDC589F}" vid="{4A3C46E8-61CC-4603-A589-7422A47A8E4A}"/>
+      <thm15:themeFamily xmlns:thm15="http://schemas.microsoft.com/office/thememl/2012/main" name="Office Theme" id="{62F939B6-93AF-4DB8-9C6B-D6C7DFDC589F}" vid="{4A3C46E8-61CC-4603-A589-7422A47A8E4A}"/>
     </a:ext>
   </a:extLst>
 </a:theme>
@@ -3034,44 +4435,44 @@
         <a:sysClr val="window" lastClr="FFFFFF"/>
       </a:lt1>
       <a:dk2>
-        <a:srgbClr val="1F497D"/>
+        <a:srgbClr val="44546A"/>
       </a:dk2>
       <a:lt2>
-        <a:srgbClr val="EEECE1"/>
+        <a:srgbClr val="E7E6E6"/>
       </a:lt2>
       <a:accent1>
-        <a:srgbClr val="4F81BD"/>
+        <a:srgbClr val="5B9BD5"/>
       </a:accent1>
       <a:accent2>
-        <a:srgbClr val="C0504D"/>
+        <a:srgbClr val="ED7D31"/>
       </a:accent2>
       <a:accent3>
-        <a:srgbClr val="9BBB59"/>
+        <a:srgbClr val="A5A5A5"/>
       </a:accent3>
       <a:accent4>
-        <a:srgbClr val="8064A2"/>
+        <a:srgbClr val="FFC000"/>
       </a:accent4>
       <a:accent5>
-        <a:srgbClr val="4BACC6"/>
+        <a:srgbClr val="4472C4"/>
       </a:accent5>
       <a:accent6>
-        <a:srgbClr val="F79646"/>
+        <a:srgbClr val="70AD47"/>
       </a:accent6>
       <a:hlink>
-        <a:srgbClr val="0000FF"/>
+        <a:srgbClr val="0563C1"/>
       </a:hlink>
       <a:folHlink>
-        <a:srgbClr val="800080"/>
+        <a:srgbClr val="954F72"/>
       </a:folHlink>
     </a:clrScheme>
     <a:fontScheme name="Office">
       <a:majorFont>
-        <a:latin typeface="Calibri"/>
+        <a:latin typeface="Calibri Light" panose="020F0302020204030204"/>
         <a:ea typeface=""/>
         <a:cs typeface=""/>
-        <a:font script="Jpan" typeface="ＭＳ Ｐゴシック"/>
+        <a:font script="Jpan" typeface="游ゴシック Light"/>
         <a:font script="Hang" typeface="맑은 고딕"/>
-        <a:font script="Hans" typeface="宋体"/>
+        <a:font script="Hans" typeface="等线 Light"/>
         <a:font script="Hant" typeface="新細明體"/>
         <a:font script="Arab" typeface="Times New Roman"/>
         <a:font script="Hebr" typeface="Times New Roman"/>
@@ -3101,12 +4502,12 @@
         <a:font script="Geor" typeface="Sylfaen"/>
       </a:majorFont>
       <a:minorFont>
-        <a:latin typeface="Calibri"/>
+        <a:latin typeface="Calibri" panose="020F0502020204030204"/>
         <a:ea typeface=""/>
         <a:cs typeface=""/>
-        <a:font script="Jpan" typeface="ＭＳ Ｐゴシック"/>
+        <a:font script="Jpan" typeface="游ゴシック"/>
         <a:font script="Hang" typeface="맑은 고딕"/>
-        <a:font script="Hans" typeface="宋体"/>
+        <a:font script="Hans" typeface="等线"/>
         <a:font script="Hant" typeface="新細明體"/>
         <a:font script="Arab" typeface="Arial"/>
         <a:font script="Hebr" typeface="Arial"/>
@@ -3145,165 +4546,141 @@
           <a:gsLst>
             <a:gs pos="0">
               <a:schemeClr val="phClr">
-                <a:tint val="50000"/>
-                <a:satMod val="300000"/>
+                <a:lumMod val="110000"/>
+                <a:satMod val="105000"/>
+                <a:tint val="67000"/>
               </a:schemeClr>
             </a:gs>
-            <a:gs pos="35000">
+            <a:gs pos="50000">
               <a:schemeClr val="phClr">
-                <a:tint val="37000"/>
-                <a:satMod val="300000"/>
+                <a:lumMod val="105000"/>
+                <a:satMod val="103000"/>
+                <a:tint val="73000"/>
               </a:schemeClr>
             </a:gs>
             <a:gs pos="100000">
               <a:schemeClr val="phClr">
-                <a:tint val="15000"/>
-                <a:satMod val="350000"/>
+                <a:lumMod val="105000"/>
+                <a:satMod val="109000"/>
+                <a:tint val="81000"/>
               </a:schemeClr>
             </a:gs>
           </a:gsLst>
-          <a:lin ang="16200000" scaled="1"/>
+          <a:lin ang="5400000" scaled="0"/>
         </a:gradFill>
         <a:gradFill rotWithShape="1">
           <a:gsLst>
             <a:gs pos="0">
               <a:schemeClr val="phClr">
-                <a:shade val="51000"/>
-                <a:satMod val="130000"/>
+                <a:satMod val="103000"/>
+                <a:lumMod val="102000"/>
+                <a:tint val="94000"/>
               </a:schemeClr>
             </a:gs>
-            <a:gs pos="80000">
+            <a:gs pos="50000">
               <a:schemeClr val="phClr">
-                <a:shade val="93000"/>
-                <a:satMod val="130000"/>
+                <a:satMod val="110000"/>
+                <a:lumMod val="100000"/>
+                <a:shade val="100000"/>
               </a:schemeClr>
             </a:gs>
             <a:gs pos="100000">
               <a:schemeClr val="phClr">
-                <a:shade val="94000"/>
-                <a:satMod val="135000"/>
+                <a:lumMod val="99000"/>
+                <a:satMod val="120000"/>
+                <a:shade val="78000"/>
               </a:schemeClr>
             </a:gs>
           </a:gsLst>
-          <a:lin ang="16200000" scaled="0"/>
+          <a:lin ang="5400000" scaled="0"/>
         </a:gradFill>
       </a:fillStyleLst>
       <a:lnStyleLst>
-        <a:ln w="9525" cap="flat" cmpd="sng" algn="ctr">
-          <a:solidFill>
-            <a:schemeClr val="phClr">
-              <a:shade val="95000"/>
-              <a:satMod val="105000"/>
-            </a:schemeClr>
-          </a:solidFill>
-          <a:prstDash val="solid"/>
-        </a:ln>
-        <a:ln w="25400" cap="flat" cmpd="sng" algn="ctr">
+        <a:ln w="6350" cap="flat" cmpd="sng" algn="ctr">
           <a:solidFill>
             <a:schemeClr val="phClr"/>
           </a:solidFill>
           <a:prstDash val="solid"/>
+          <a:miter lim="800000"/>
         </a:ln>
-        <a:ln w="38100" cap="flat" cmpd="sng" algn="ctr">
+        <a:ln w="12700" cap="flat" cmpd="sng" algn="ctr">
           <a:solidFill>
             <a:schemeClr val="phClr"/>
           </a:solidFill>
           <a:prstDash val="solid"/>
+          <a:miter lim="800000"/>
+        </a:ln>
+        <a:ln w="19050" cap="flat" cmpd="sng" algn="ctr">
+          <a:solidFill>
+            <a:schemeClr val="phClr"/>
+          </a:solidFill>
+          <a:prstDash val="solid"/>
+          <a:miter lim="800000"/>
         </a:ln>
       </a:lnStyleLst>
       <a:effectStyleLst>
         <a:effectStyle>
+          <a:effectLst/>
+        </a:effectStyle>
+        <a:effectStyle>
+          <a:effectLst/>
+        </a:effectStyle>
+        <a:effectStyle>
           <a:effectLst>
-            <a:outerShdw blurRad="40000" dist="20000" dir="5400000" rotWithShape="0">
+            <a:outerShdw blurRad="57150" dist="19050" dir="5400000" algn="ctr" rotWithShape="0">
               <a:srgbClr val="000000">
-                <a:alpha val="38000"/>
+                <a:alpha val="63000"/>
               </a:srgbClr>
             </a:outerShdw>
           </a:effectLst>
-        </a:effectStyle>
-        <a:effectStyle>
-          <a:effectLst>
-            <a:outerShdw blurRad="40000" dist="23000" dir="5400000" rotWithShape="0">
-              <a:srgbClr val="000000">
-                <a:alpha val="35000"/>
-              </a:srgbClr>
-            </a:outerShdw>
-          </a:effectLst>
-        </a:effectStyle>
-        <a:effectStyle>
-          <a:effectLst>
-            <a:outerShdw blurRad="40000" dist="23000" dir="5400000" rotWithShape="0">
-              <a:srgbClr val="000000">
-                <a:alpha val="35000"/>
-              </a:srgbClr>
-            </a:outerShdw>
-          </a:effectLst>
-          <a:scene3d>
-            <a:camera prst="orthographicFront">
-              <a:rot lat="0" lon="0" rev="0"/>
-            </a:camera>
-            <a:lightRig rig="threePt" dir="t">
-              <a:rot lat="0" lon="0" rev="1200000"/>
-            </a:lightRig>
-          </a:scene3d>
-          <a:sp3d>
-            <a:bevelT w="63500" h="25400"/>
-          </a:sp3d>
         </a:effectStyle>
       </a:effectStyleLst>
       <a:bgFillStyleLst>
         <a:solidFill>
           <a:schemeClr val="phClr"/>
         </a:solidFill>
+        <a:solidFill>
+          <a:schemeClr val="phClr">
+            <a:tint val="95000"/>
+            <a:satMod val="170000"/>
+          </a:schemeClr>
+        </a:solidFill>
         <a:gradFill rotWithShape="1">
           <a:gsLst>
             <a:gs pos="0">
               <a:schemeClr val="phClr">
-                <a:tint val="40000"/>
-                <a:satMod val="350000"/>
+                <a:tint val="93000"/>
+                <a:satMod val="150000"/>
+                <a:shade val="98000"/>
+                <a:lumMod val="102000"/>
               </a:schemeClr>
             </a:gs>
-            <a:gs pos="40000">
+            <a:gs pos="50000">
               <a:schemeClr val="phClr">
-                <a:tint val="45000"/>
-                <a:shade val="99000"/>
-                <a:satMod val="350000"/>
+                <a:tint val="98000"/>
+                <a:satMod val="130000"/>
+                <a:shade val="90000"/>
+                <a:lumMod val="103000"/>
               </a:schemeClr>
             </a:gs>
             <a:gs pos="100000">
               <a:schemeClr val="phClr">
-                <a:shade val="20000"/>
-                <a:satMod val="255000"/>
+                <a:shade val="63000"/>
+                <a:satMod val="120000"/>
               </a:schemeClr>
             </a:gs>
           </a:gsLst>
-          <a:path path="circle">
-            <a:fillToRect l="50000" t="-80000" r="50000" b="180000"/>
-          </a:path>
-        </a:gradFill>
-        <a:gradFill rotWithShape="1">
-          <a:gsLst>
-            <a:gs pos="0">
-              <a:schemeClr val="phClr">
-                <a:tint val="80000"/>
-                <a:satMod val="300000"/>
-              </a:schemeClr>
-            </a:gs>
-            <a:gs pos="100000">
-              <a:schemeClr val="phClr">
-                <a:shade val="30000"/>
-                <a:satMod val="200000"/>
-              </a:schemeClr>
-            </a:gs>
-          </a:gsLst>
-          <a:path path="circle">
-            <a:fillToRect l="50000" t="50000" r="50000" b="50000"/>
-          </a:path>
+          <a:lin ang="5400000" scaled="0"/>
         </a:gradFill>
       </a:bgFillStyleLst>
     </a:fmtScheme>
   </a:themeElements>
   <a:objectDefaults/>
   <a:extraClrSchemeLst/>
+  <a:extLst>
+    <a:ext uri="{05A4C25C-085E-4340-85A3-A5531E510DB2}">
+      <thm15:themeFamily xmlns:thm15="http://schemas.microsoft.com/office/thememl/2012/main" name="Office Theme" id="{62F939B6-93AF-4DB8-9C6B-D6C7DFDC589F}" vid="{4A3C46E8-61CC-4603-A589-7422A47A8E4A}"/>
+    </a:ext>
+  </a:extLst>
 </a:theme>
 </file>
</xml_diff>